<commit_message>
Rewrite GPU proposal slides in Korean with corrected narrative
Kimi-VL is already self-hosted internally. The proposal now argues
for separate H200 GPUs dedicated to GUI-specialized models, running
independently from the existing Kimi-VL server.

Co-Authored-By: Claude Opus 4.6 <noreply@anthropic.com>
</commit_message>
<xml_diff>
--- a/docs/gui_vlm_gpu_h200_proposal.pptx
+++ b/docs/gui_vlm_gpu_h200_proposal.pptx
@@ -3130,11 +3130,11 @@
                 <a:solidFill>
                   <a:srgbClr val="38BDF8"/>
                 </a:solidFill>
-                <a:latin typeface="Segoe UI"/>
-              </a:defRPr>
-            </a:pPr>
-            <a:r>
-              <a:t>GUI-Specialized VLM for CD-SEM/RCS Automation</a:t>
+                <a:latin typeface="Malgun Gothic"/>
+              </a:defRPr>
+            </a:pPr>
+            <a:r>
+              <a:t>GUI 자동화 전용 VLM 모델 도입 제안</a:t>
             </a:r>
           </a:p>
         </p:txBody>
@@ -3166,11 +3166,11 @@
                 <a:solidFill>
                   <a:srgbClr val="818CF8"/>
                 </a:solidFill>
-                <a:latin typeface="Segoe UI"/>
-              </a:defRPr>
-            </a:pPr>
-            <a:r>
-              <a:t>Why Kimi-VL Is Not Enough &amp; Why We Need GPU H200 x2</a:t>
+                <a:latin typeface="Malgun Gothic"/>
+              </a:defRPr>
+            </a:pPr>
+            <a:r>
+              <a:t>CD-SEM / RCS 레시피 자동화를 위한 GPU H200 x 2 도입 필요성</a:t>
             </a:r>
           </a:p>
         </p:txBody>
@@ -3202,11 +3202,11 @@
                 <a:solidFill>
                   <a:srgbClr val="94A3B8"/>
                 </a:solidFill>
-                <a:latin typeface="Segoe UI"/>
-              </a:defRPr>
-            </a:pPr>
-            <a:r>
-              <a:t>Benchmark-Driven Proposal for Self-Hosted GUI Agent Models</a:t>
+                <a:latin typeface="Malgun Gothic"/>
+              </a:defRPr>
+            </a:pPr>
+            <a:r>
+              <a:t>벤치마크 기반 분석 — 범용 VLM vs GUI 전문 모델 성능 비교</a:t>
             </a:r>
           </a:p>
         </p:txBody>
@@ -3219,7 +3219,47 @@
         </p:nvSpPr>
         <p:spPr>
           <a:xfrm>
-            <a:off x="1371600" y="5029200"/>
+            <a:off x="1371600" y="4572000"/>
+            <a:ext cx="9144000" cy="731520"/>
+          </a:xfrm>
+          <a:prstGeom prst="rect">
+            <a:avLst/>
+          </a:prstGeom>
+          <a:noFill/>
+        </p:spPr>
+        <p:txBody>
+          <a:bodyPr wrap="square">
+            <a:spAutoFit/>
+          </a:bodyPr>
+          <a:lstStyle/>
+          <a:p>
+            <a:pPr algn="l">
+              <a:defRPr sz="1400" b="0">
+                <a:solidFill>
+                  <a:srgbClr val="FBBF24"/>
+                </a:solidFill>
+                <a:latin typeface="Malgun Gothic"/>
+              </a:defRPr>
+            </a:pPr>
+            <a:r>
+              <a:t>현황: Kimi-VL은 사내 서버에서 자체 운영 중 (API 서빙)</a:t>
+            </a:r>
+            <a:br/>
+            <a:r>
+              <a:t>제안: GUI 자동화 전용 모델을 별도 GPU에서 운영</a:t>
+            </a:r>
+          </a:p>
+        </p:txBody>
+      </p:sp>
+      <p:sp>
+        <p:nvSpPr>
+          <p:cNvPr id="6" name="TextBox 5"/>
+          <p:cNvSpPr txBox="1"/>
+          <p:nvPr/>
+        </p:nvSpPr>
+        <p:spPr>
+          <a:xfrm>
+            <a:off x="1371600" y="5669280"/>
             <a:ext cx="9144000" cy="457200"/>
           </a:xfrm>
           <a:prstGeom prst="rect">
@@ -3238,11 +3278,11 @@
                 <a:solidFill>
                   <a:srgbClr val="94A3B8"/>
                 </a:solidFill>
-                <a:latin typeface="Segoe UI"/>
-              </a:defRPr>
-            </a:pPr>
-            <a:r>
-              <a:t>February 2026</a:t>
+                <a:latin typeface="Malgun Gothic"/>
+              </a:defRPr>
+            </a:pPr>
+            <a:r>
+              <a:t>2026년 2월</a:t>
             </a:r>
           </a:p>
         </p:txBody>
@@ -3282,7 +3322,7 @@
         <p:spPr>
           <a:xfrm>
             <a:off x="731520" y="274320"/>
-            <a:ext cx="10058400" cy="731520"/>
+            <a:ext cx="10972800" cy="731520"/>
           </a:xfrm>
           <a:prstGeom prst="rect">
             <a:avLst/>
@@ -3300,11 +3340,11 @@
                 <a:solidFill>
                   <a:srgbClr val="F87171"/>
                 </a:solidFill>
-                <a:latin typeface="Segoe UI"/>
-              </a:defRPr>
-            </a:pPr>
-            <a:r>
-              <a:t>Problem: Kimi-VL Cannot Handle Complex Engineering UIs</a:t>
+                <a:latin typeface="Malgun Gothic"/>
+              </a:defRPr>
+            </a:pPr>
+            <a:r>
+              <a:t>문제: 현재 Kimi-VL로는 복잡한 엔지니어링 UI를 처리할 수 없음</a:t>
             </a:r>
           </a:p>
         </p:txBody>
@@ -3381,11 +3421,11 @@
                 <a:solidFill>
                   <a:srgbClr val="F87171"/>
                 </a:solidFill>
-                <a:latin typeface="Segoe UI"/>
-              </a:defRPr>
-            </a:pPr>
-            <a:r>
-              <a:t>Kimi-VL Current Performance</a:t>
+                <a:latin typeface="Malgun Gothic"/>
+              </a:defRPr>
+            </a:pPr>
+            <a:r>
+              <a:t>Kimi-VL 현재 성능 한계</a:t>
             </a:r>
           </a:p>
         </p:txBody>
@@ -3420,11 +3460,11 @@
                 <a:solidFill>
                   <a:srgbClr val="94A3B8"/>
                 </a:solidFill>
-                <a:latin typeface="Segoe UI"/>
-              </a:defRPr>
-            </a:pPr>
-            <a:r>
-              <a:t>  34.5% accuracy on ScreenSpot-Pro benchmark</a:t>
+                <a:latin typeface="Malgun Gothic"/>
+              </a:defRPr>
+            </a:pPr>
+            <a:r>
+              <a:t>  ScreenSpot-Pro 벤치마크 정확도: 34.5%</a:t>
             </a:r>
           </a:p>
           <a:p>
@@ -3436,11 +3476,11 @@
                 <a:solidFill>
                   <a:srgbClr val="94A3B8"/>
                 </a:solidFill>
-                <a:latin typeface="Segoe UI"/>
-              </a:defRPr>
-            </a:pPr>
-            <a:r>
-              <a:t>  Misses 2 out of every 3 click targets on professional UIs</a:t>
+                <a:latin typeface="Malgun Gothic"/>
+              </a:defRPr>
+            </a:pPr>
+            <a:r>
+              <a:t>  전문 UI에서 클릭 타겟 3개 중 2개를 놓침</a:t>
             </a:r>
           </a:p>
           <a:p>
@@ -3452,11 +3492,11 @@
                 <a:solidFill>
                   <a:srgbClr val="94A3B8"/>
                 </a:solidFill>
-                <a:latin typeface="Segoe UI"/>
-              </a:defRPr>
-            </a:pPr>
-            <a:r>
-              <a:t>  General-purpose model not trained on GUI interaction data</a:t>
+                <a:latin typeface="Malgun Gothic"/>
+              </a:defRPr>
+            </a:pPr>
+            <a:r>
+              <a:t>  범용 모델 — GUI 인터랙션 데이터로 학습되지 않음</a:t>
             </a:r>
           </a:p>
           <a:p>
@@ -3468,11 +3508,11 @@
                 <a:solidFill>
                   <a:srgbClr val="94A3B8"/>
                 </a:solidFill>
-                <a:latin typeface="Segoe UI"/>
-              </a:defRPr>
-            </a:pPr>
-            <a:r>
-              <a:t>  Icon/widget detection near-zero on engineering software</a:t>
+                <a:latin typeface="Malgun Gothic"/>
+              </a:defRPr>
+            </a:pPr>
+            <a:r>
+              <a:t>  아이콘/위젯 감지 능력이 엔지니어링 소프트웨어에서 거의 0%</a:t>
             </a:r>
           </a:p>
           <a:p>
@@ -3484,11 +3524,11 @@
                 <a:solidFill>
                   <a:srgbClr val="94A3B8"/>
                 </a:solidFill>
-                <a:latin typeface="Segoe UI"/>
-              </a:defRPr>
-            </a:pPr>
-            <a:r>
-              <a:t>  API-only: latency, cost, and vendor lock-in risks</a:t>
+                <a:latin typeface="Malgun Gothic"/>
+              </a:defRPr>
+            </a:pPr>
+            <a:r>
+              <a:t>  사내 운영 중이나, 범용 모델의 근본적 한계 존재</a:t>
             </a:r>
           </a:p>
           <a:p>
@@ -3500,11 +3540,11 @@
                 <a:solidFill>
                   <a:srgbClr val="94A3B8"/>
                 </a:solidFill>
-                <a:latin typeface="Segoe UI"/>
-              </a:defRPr>
-            </a:pPr>
-            <a:r>
-              <a:t>  No fine-tuning possible on proprietary RCS screenshots</a:t>
+                <a:latin typeface="Malgun Gothic"/>
+              </a:defRPr>
+            </a:pPr>
+            <a:r>
+              <a:t>  RCS/CD-SEM 전용 파인튜닝이 불가능한 구조</a:t>
             </a:r>
           </a:p>
         </p:txBody>
@@ -3581,11 +3621,11 @@
                 <a:solidFill>
                   <a:srgbClr val="F87171"/>
                 </a:solidFill>
-                <a:latin typeface="Segoe UI"/>
-              </a:defRPr>
-            </a:pPr>
-            <a:r>
-              <a:t>Critical: Narrow-Range Element Failure</a:t>
+                <a:latin typeface="Malgun Gothic"/>
+              </a:defRPr>
+            </a:pPr>
+            <a:r>
+              <a:t>핵심 문제: 좁은 영역 UI 요소 인식 실패</a:t>
             </a:r>
           </a:p>
         </p:txBody>
@@ -3620,11 +3660,11 @@
                 <a:solidFill>
                   <a:srgbClr val="94A3B8"/>
                 </a:solidFill>
-                <a:latin typeface="Segoe UI"/>
-              </a:defRPr>
-            </a:pPr>
-            <a:r>
-              <a:t>  When UI elements are packed in a narrow region (&lt;20px apart),</a:t>
+                <a:latin typeface="Malgun Gothic"/>
+              </a:defRPr>
+            </a:pPr>
+            <a:r>
+              <a:t>  UI 요소가 좁은 영역에 밀집되어 있을 때 (&lt;20px 간격),</a:t>
             </a:r>
           </a:p>
           <a:p>
@@ -3636,11 +3676,11 @@
                 <a:solidFill>
                   <a:srgbClr val="94A3B8"/>
                 </a:solidFill>
-                <a:latin typeface="Segoe UI"/>
-              </a:defRPr>
-            </a:pPr>
-            <a:r>
-              <a:t>  Kimi-VL CANNOT distinguish adjacent elements:</a:t>
+                <a:latin typeface="Malgun Gothic"/>
+              </a:defRPr>
+            </a:pPr>
+            <a:r>
+              <a:t>  Kimi-VL은 인접 요소를 구분하지 못합니다:</a:t>
             </a:r>
           </a:p>
           <a:p>
@@ -3652,7 +3692,7 @@
                 <a:solidFill>
                   <a:srgbClr val="94A3B8"/>
                 </a:solidFill>
-                <a:latin typeface="Segoe UI"/>
+                <a:latin typeface="Malgun Gothic"/>
               </a:defRPr>
             </a:pPr>
           </a:p>
@@ -3665,11 +3705,11 @@
                 <a:solidFill>
                   <a:srgbClr val="94A3B8"/>
                 </a:solidFill>
-                <a:latin typeface="Segoe UI"/>
-              </a:defRPr>
-            </a:pPr>
-            <a:r>
-              <a:t>  - Click coordinates drift to neighboring buttons/labels</a:t>
+                <a:latin typeface="Malgun Gothic"/>
+              </a:defRPr>
+            </a:pPr>
+            <a:r>
+              <a:t>  - 클릭 좌표가 인접 버튼/라벨로 이탈</a:t>
             </a:r>
           </a:p>
           <a:p>
@@ -3681,11 +3721,11 @@
                 <a:solidFill>
                   <a:srgbClr val="94A3B8"/>
                 </a:solidFill>
-                <a:latin typeface="Segoe UI"/>
-              </a:defRPr>
-            </a:pPr>
-            <a:r>
-              <a:t>  - Toolbar icon clusters produce ambiguous outputs</a:t>
+                <a:latin typeface="Malgun Gothic"/>
+              </a:defRPr>
+            </a:pPr>
+            <a:r>
+              <a:t>  - 툴바 아이콘 클러스터에서 모호한 좌표 출력</a:t>
             </a:r>
           </a:p>
           <a:p>
@@ -3697,11 +3737,11 @@
                 <a:solidFill>
                   <a:srgbClr val="94A3B8"/>
                 </a:solidFill>
-                <a:latin typeface="Segoe UI"/>
-              </a:defRPr>
-            </a:pPr>
-            <a:r>
-              <a:t>  - Tree-view / list-view rows confused at small row heights</a:t>
+                <a:latin typeface="Malgun Gothic"/>
+              </a:defRPr>
+            </a:pPr>
+            <a:r>
+              <a:t>  - TreeView / ListView 행 높이가 작으면 행 혼동</a:t>
             </a:r>
           </a:p>
           <a:p>
@@ -3713,11 +3753,11 @@
                 <a:solidFill>
                   <a:srgbClr val="94A3B8"/>
                 </a:solidFill>
-                <a:latin typeface="Segoe UI"/>
-              </a:defRPr>
-            </a:pPr>
-            <a:r>
-              <a:t>  - RCS recipe editor has dense panels with &lt;10px spacing</a:t>
+                <a:latin typeface="Malgun Gothic"/>
+              </a:defRPr>
+            </a:pPr>
+            <a:r>
+              <a:t>  - RCS 레시피 편집기는 &lt;10px 간격의 밀집 패널 보유</a:t>
             </a:r>
           </a:p>
           <a:p>
@@ -3729,7 +3769,7 @@
                 <a:solidFill>
                   <a:srgbClr val="94A3B8"/>
                 </a:solidFill>
-                <a:latin typeface="Segoe UI"/>
+                <a:latin typeface="Malgun Gothic"/>
               </a:defRPr>
             </a:pPr>
           </a:p>
@@ -3742,11 +3782,11 @@
                 <a:solidFill>
                   <a:srgbClr val="94A3B8"/>
                 </a:solidFill>
-                <a:latin typeface="Segoe UI"/>
-              </a:defRPr>
-            </a:pPr>
-            <a:r>
-              <a:t>  Root cause: No GUI spatial training. General VLMs are</a:t>
+                <a:latin typeface="Malgun Gothic"/>
+              </a:defRPr>
+            </a:pPr>
+            <a:r>
+              <a:t>  근본 원인: GUI 공간 학습 부재</a:t>
             </a:r>
           </a:p>
           <a:p>
@@ -3758,11 +3798,11 @@
                 <a:solidFill>
                   <a:srgbClr val="94A3B8"/>
                 </a:solidFill>
-                <a:latin typeface="Segoe UI"/>
-              </a:defRPr>
-            </a:pPr>
-            <a:r>
-              <a:t>  trained on natural images, not dense engineering UIs.</a:t>
+                <a:latin typeface="Malgun Gothic"/>
+              </a:defRPr>
+            </a:pPr>
+            <a:r>
+              <a:t>  범용 VLM은 자연 이미지/문서로 학습 → 밀집 UI에 약함</a:t>
             </a:r>
           </a:p>
           <a:p>
@@ -3774,11 +3814,11 @@
                 <a:solidFill>
                   <a:srgbClr val="94A3B8"/>
                 </a:solidFill>
-                <a:latin typeface="Segoe UI"/>
-              </a:defRPr>
-            </a:pPr>
-            <a:r>
-              <a:t>  Accuracy degrades rapidly as target size decreases.</a:t>
+                <a:latin typeface="Malgun Gothic"/>
+              </a:defRPr>
+            </a:pPr>
+            <a:r>
+              <a:t>  타겟 크기가 줄어들수록 정확도가 급격히 하락</a:t>
             </a:r>
           </a:p>
           <a:p>
@@ -3790,11 +3830,11 @@
                 <a:solidFill>
                   <a:srgbClr val="94A3B8"/>
                 </a:solidFill>
-                <a:latin typeface="Segoe UI"/>
-              </a:defRPr>
-            </a:pPr>
-            <a:r>
-              <a:t>  Icon-only grounding drops to &lt; 5% for general models.</a:t>
+                <a:latin typeface="Malgun Gothic"/>
+              </a:defRPr>
+            </a:pPr>
+            <a:r>
+              <a:t>  아이콘 전용 그라운딩은 범용 모델에서 &lt; 5% 정확도</a:t>
             </a:r>
           </a:p>
         </p:txBody>
@@ -3852,11 +3892,11 @@
                 <a:solidFill>
                   <a:srgbClr val="38BDF8"/>
                 </a:solidFill>
-                <a:latin typeface="Segoe UI"/>
-              </a:defRPr>
-            </a:pPr>
-            <a:r>
-              <a:t>ScreenSpot-Pro: Professional GUI Grounding Benchmark</a:t>
+                <a:latin typeface="Malgun Gothic"/>
+              </a:defRPr>
+            </a:pPr>
+            <a:r>
+              <a:t>ScreenSpot-Pro: 전문 GUI 그라운딩 벤치마크</a:t>
             </a:r>
           </a:p>
         </p:txBody>
@@ -3888,11 +3928,11 @@
                 <a:solidFill>
                   <a:srgbClr val="94A3B8"/>
                 </a:solidFill>
-                <a:latin typeface="Segoe UI"/>
-              </a:defRPr>
-            </a:pPr>
-            <a:r>
-              <a:t>Click-point accuracy on high-resolution professional application UIs (CAD, EDA, dev tools) — closest benchmark to CD-SEM/RCS use case</a:t>
+                <a:latin typeface="Malgun Gothic"/>
+              </a:defRPr>
+            </a:pPr>
+            <a:r>
+              <a:t>고해상도 전문 애플리케이션 UI (CAD, EDA, 개발 도구)에서의 클릭 좌표 정확도 — CD-SEM/RCS 유즈케이스에 가장 유사한 공개 벤치마크</a:t>
             </a:r>
           </a:p>
         </p:txBody>
@@ -3949,7 +3989,7 @@
         <p:spPr>
           <a:xfrm>
             <a:off x="822960" y="1463040"/>
-            <a:ext cx="3657600" cy="329184"/>
+            <a:ext cx="3840480" cy="329184"/>
           </a:xfrm>
           <a:prstGeom prst="rect">
             <a:avLst/>
@@ -3967,11 +4007,11 @@
                 <a:solidFill>
                   <a:srgbClr val="38BDF8"/>
                 </a:solidFill>
-                <a:latin typeface="Segoe UI"/>
-              </a:defRPr>
-            </a:pPr>
-            <a:r>
-              <a:t>Model</a:t>
+                <a:latin typeface="Malgun Gothic"/>
+              </a:defRPr>
+            </a:pPr>
+            <a:r>
+              <a:t>모델</a:t>
             </a:r>
           </a:p>
         </p:txBody>
@@ -3984,8 +4024,8 @@
         </p:nvSpPr>
         <p:spPr>
           <a:xfrm>
-            <a:off x="4480560" y="1463040"/>
-            <a:ext cx="1371600" cy="329184"/>
+            <a:off x="4663440" y="1463040"/>
+            <a:ext cx="1188720" cy="329184"/>
           </a:xfrm>
           <a:prstGeom prst="rect">
             <a:avLst/>
@@ -4003,11 +4043,11 @@
                 <a:solidFill>
                   <a:srgbClr val="38BDF8"/>
                 </a:solidFill>
-                <a:latin typeface="Segoe UI"/>
-              </a:defRPr>
-            </a:pPr>
-            <a:r>
-              <a:t>Type</a:t>
+                <a:latin typeface="Malgun Gothic"/>
+              </a:defRPr>
+            </a:pPr>
+            <a:r>
+              <a:t>유형</a:t>
             </a:r>
           </a:p>
         </p:txBody>
@@ -4039,11 +4079,11 @@
                 <a:solidFill>
                   <a:srgbClr val="38BDF8"/>
                 </a:solidFill>
-                <a:latin typeface="Segoe UI"/>
-              </a:defRPr>
-            </a:pPr>
-            <a:r>
-              <a:t>Params</a:t>
+                <a:latin typeface="Malgun Gothic"/>
+              </a:defRPr>
+            </a:pPr>
+            <a:r>
+              <a:t>파라미터</a:t>
             </a:r>
           </a:p>
         </p:txBody>
@@ -4075,7 +4115,7 @@
                 <a:solidFill>
                   <a:srgbClr val="38BDF8"/>
                 </a:solidFill>
-                <a:latin typeface="Segoe UI"/>
+                <a:latin typeface="Malgun Gothic"/>
               </a:defRPr>
             </a:pPr>
             <a:r>
@@ -4136,7 +4176,7 @@
         <p:spPr>
           <a:xfrm>
             <a:off x="822960" y="1792224"/>
-            <a:ext cx="3657600" cy="329184"/>
+            <a:ext cx="3840480" cy="329184"/>
           </a:xfrm>
           <a:prstGeom prst="rect">
             <a:avLst/>
@@ -4154,7 +4194,7 @@
                 <a:solidFill>
                   <a:srgbClr val="E2E8F0"/>
                 </a:solidFill>
-                <a:latin typeface="Segoe UI"/>
+                <a:latin typeface="Malgun Gothic"/>
               </a:defRPr>
             </a:pPr>
             <a:r>
@@ -4171,8 +4211,8 @@
         </p:nvSpPr>
         <p:spPr>
           <a:xfrm>
-            <a:off x="4480560" y="1792224"/>
-            <a:ext cx="1371600" cy="329184"/>
+            <a:off x="4663440" y="1792224"/>
+            <a:ext cx="1188720" cy="329184"/>
           </a:xfrm>
           <a:prstGeom prst="rect">
             <a:avLst/>
@@ -4190,11 +4230,11 @@
                 <a:solidFill>
                   <a:srgbClr val="4ADE80"/>
                 </a:solidFill>
-                <a:latin typeface="Segoe UI"/>
-              </a:defRPr>
-            </a:pPr>
-            <a:r>
-              <a:t>GUI-Trained</a:t>
+                <a:latin typeface="Malgun Gothic"/>
+              </a:defRPr>
+            </a:pPr>
+            <a:r>
+              <a:t>GUI 전용</a:t>
             </a:r>
           </a:p>
         </p:txBody>
@@ -4226,7 +4266,7 @@
                 <a:solidFill>
                   <a:srgbClr val="94A3B8"/>
                 </a:solidFill>
-                <a:latin typeface="Segoe UI"/>
+                <a:latin typeface="Malgun Gothic"/>
               </a:defRPr>
             </a:pPr>
             <a:r>
@@ -4262,7 +4302,7 @@
                 <a:solidFill>
                   <a:srgbClr val="4ADE80"/>
                 </a:solidFill>
-                <a:latin typeface="Segoe UI"/>
+                <a:latin typeface="Malgun Gothic"/>
               </a:defRPr>
             </a:pPr>
             <a:r>
@@ -4323,7 +4363,7 @@
         <p:spPr>
           <a:xfrm>
             <a:off x="822960" y="2121408"/>
-            <a:ext cx="3657600" cy="329184"/>
+            <a:ext cx="3840480" cy="329184"/>
           </a:xfrm>
           <a:prstGeom prst="rect">
             <a:avLst/>
@@ -4341,7 +4381,7 @@
                 <a:solidFill>
                   <a:srgbClr val="E2E8F0"/>
                 </a:solidFill>
-                <a:latin typeface="Segoe UI"/>
+                <a:latin typeface="Malgun Gothic"/>
               </a:defRPr>
             </a:pPr>
             <a:r>
@@ -4358,8 +4398,8 @@
         </p:nvSpPr>
         <p:spPr>
           <a:xfrm>
-            <a:off x="4480560" y="2121408"/>
-            <a:ext cx="1371600" cy="329184"/>
+            <a:off x="4663440" y="2121408"/>
+            <a:ext cx="1188720" cy="329184"/>
           </a:xfrm>
           <a:prstGeom prst="rect">
             <a:avLst/>
@@ -4377,11 +4417,11 @@
                 <a:solidFill>
                   <a:srgbClr val="4ADE80"/>
                 </a:solidFill>
-                <a:latin typeface="Segoe UI"/>
-              </a:defRPr>
-            </a:pPr>
-            <a:r>
-              <a:t>GUI-Trained</a:t>
+                <a:latin typeface="Malgun Gothic"/>
+              </a:defRPr>
+            </a:pPr>
+            <a:r>
+              <a:t>GUI 전용</a:t>
             </a:r>
           </a:p>
         </p:txBody>
@@ -4413,7 +4453,7 @@
                 <a:solidFill>
                   <a:srgbClr val="94A3B8"/>
                 </a:solidFill>
-                <a:latin typeface="Segoe UI"/>
+                <a:latin typeface="Malgun Gothic"/>
               </a:defRPr>
             </a:pPr>
             <a:r>
@@ -4449,7 +4489,7 @@
                 <a:solidFill>
                   <a:srgbClr val="4ADE80"/>
                 </a:solidFill>
-                <a:latin typeface="Segoe UI"/>
+                <a:latin typeface="Malgun Gothic"/>
               </a:defRPr>
             </a:pPr>
             <a:r>
@@ -4510,7 +4550,7 @@
         <p:spPr>
           <a:xfrm>
             <a:off x="822960" y="2450592"/>
-            <a:ext cx="3657600" cy="329184"/>
+            <a:ext cx="3840480" cy="329184"/>
           </a:xfrm>
           <a:prstGeom prst="rect">
             <a:avLst/>
@@ -4528,7 +4568,7 @@
                 <a:solidFill>
                   <a:srgbClr val="E2E8F0"/>
                 </a:solidFill>
-                <a:latin typeface="Segoe UI"/>
+                <a:latin typeface="Malgun Gothic"/>
               </a:defRPr>
             </a:pPr>
             <a:r>
@@ -4545,8 +4585,8 @@
         </p:nvSpPr>
         <p:spPr>
           <a:xfrm>
-            <a:off x="4480560" y="2450592"/>
-            <a:ext cx="1371600" cy="329184"/>
+            <a:off x="4663440" y="2450592"/>
+            <a:ext cx="1188720" cy="329184"/>
           </a:xfrm>
           <a:prstGeom prst="rect">
             <a:avLst/>
@@ -4564,11 +4604,11 @@
                 <a:solidFill>
                   <a:srgbClr val="FBBF24"/>
                 </a:solidFill>
-                <a:latin typeface="Segoe UI"/>
-              </a:defRPr>
-            </a:pPr>
-            <a:r>
-              <a:t>General</a:t>
+                <a:latin typeface="Malgun Gothic"/>
+              </a:defRPr>
+            </a:pPr>
+            <a:r>
+              <a:t>범용</a:t>
             </a:r>
           </a:p>
         </p:txBody>
@@ -4600,7 +4640,7 @@
                 <a:solidFill>
                   <a:srgbClr val="94A3B8"/>
                 </a:solidFill>
-                <a:latin typeface="Segoe UI"/>
+                <a:latin typeface="Malgun Gothic"/>
               </a:defRPr>
             </a:pPr>
             <a:r>
@@ -4636,7 +4676,7 @@
                 <a:solidFill>
                   <a:srgbClr val="38BDF8"/>
                 </a:solidFill>
-                <a:latin typeface="Segoe UI"/>
+                <a:latin typeface="Malgun Gothic"/>
               </a:defRPr>
             </a:pPr>
             <a:r>
@@ -4697,7 +4737,7 @@
         <p:spPr>
           <a:xfrm>
             <a:off x="822960" y="2779776"/>
-            <a:ext cx="3657600" cy="329184"/>
+            <a:ext cx="3840480" cy="329184"/>
           </a:xfrm>
           <a:prstGeom prst="rect">
             <a:avLst/>
@@ -4715,7 +4755,7 @@
                 <a:solidFill>
                   <a:srgbClr val="E2E8F0"/>
                 </a:solidFill>
-                <a:latin typeface="Segoe UI"/>
+                <a:latin typeface="Malgun Gothic"/>
               </a:defRPr>
             </a:pPr>
             <a:r>
@@ -4732,8 +4772,8 @@
         </p:nvSpPr>
         <p:spPr>
           <a:xfrm>
-            <a:off x="4480560" y="2779776"/>
-            <a:ext cx="1371600" cy="329184"/>
+            <a:off x="4663440" y="2779776"/>
+            <a:ext cx="1188720" cy="329184"/>
           </a:xfrm>
           <a:prstGeom prst="rect">
             <a:avLst/>
@@ -4751,11 +4791,11 @@
                 <a:solidFill>
                   <a:srgbClr val="4ADE80"/>
                 </a:solidFill>
-                <a:latin typeface="Segoe UI"/>
-              </a:defRPr>
-            </a:pPr>
-            <a:r>
-              <a:t>GUI-Trained</a:t>
+                <a:latin typeface="Malgun Gothic"/>
+              </a:defRPr>
+            </a:pPr>
+            <a:r>
+              <a:t>GUI 전용</a:t>
             </a:r>
           </a:p>
         </p:txBody>
@@ -4787,7 +4827,7 @@
                 <a:solidFill>
                   <a:srgbClr val="94A3B8"/>
                 </a:solidFill>
-                <a:latin typeface="Segoe UI"/>
+                <a:latin typeface="Malgun Gothic"/>
               </a:defRPr>
             </a:pPr>
             <a:r>
@@ -4823,7 +4863,7 @@
                 <a:solidFill>
                   <a:srgbClr val="38BDF8"/>
                 </a:solidFill>
-                <a:latin typeface="Segoe UI"/>
+                <a:latin typeface="Malgun Gothic"/>
               </a:defRPr>
             </a:pPr>
             <a:r>
@@ -4884,7 +4924,7 @@
         <p:spPr>
           <a:xfrm>
             <a:off x="822960" y="3108960"/>
-            <a:ext cx="3657600" cy="329184"/>
+            <a:ext cx="3840480" cy="329184"/>
           </a:xfrm>
           <a:prstGeom prst="rect">
             <a:avLst/>
@@ -4902,7 +4942,7 @@
                 <a:solidFill>
                   <a:srgbClr val="E2E8F0"/>
                 </a:solidFill>
-                <a:latin typeface="Segoe UI"/>
+                <a:latin typeface="Malgun Gothic"/>
               </a:defRPr>
             </a:pPr>
             <a:r>
@@ -4919,8 +4959,8 @@
         </p:nvSpPr>
         <p:spPr>
           <a:xfrm>
-            <a:off x="4480560" y="3108960"/>
-            <a:ext cx="1371600" cy="329184"/>
+            <a:off x="4663440" y="3108960"/>
+            <a:ext cx="1188720" cy="329184"/>
           </a:xfrm>
           <a:prstGeom prst="rect">
             <a:avLst/>
@@ -4938,11 +4978,11 @@
                 <a:solidFill>
                   <a:srgbClr val="4ADE80"/>
                 </a:solidFill>
-                <a:latin typeface="Segoe UI"/>
-              </a:defRPr>
-            </a:pPr>
-            <a:r>
-              <a:t>GUI-Trained</a:t>
+                <a:latin typeface="Malgun Gothic"/>
+              </a:defRPr>
+            </a:pPr>
+            <a:r>
+              <a:t>GUI 전용</a:t>
             </a:r>
           </a:p>
         </p:txBody>
@@ -4974,7 +5014,7 @@
                 <a:solidFill>
                   <a:srgbClr val="94A3B8"/>
                 </a:solidFill>
-                <a:latin typeface="Segoe UI"/>
+                <a:latin typeface="Malgun Gothic"/>
               </a:defRPr>
             </a:pPr>
             <a:r>
@@ -5010,7 +5050,7 @@
                 <a:solidFill>
                   <a:srgbClr val="FBBF24"/>
                 </a:solidFill>
-                <a:latin typeface="Segoe UI"/>
+                <a:latin typeface="Malgun Gothic"/>
               </a:defRPr>
             </a:pPr>
             <a:r>
@@ -5071,7 +5111,7 @@
         <p:spPr>
           <a:xfrm>
             <a:off x="822960" y="3438144"/>
-            <a:ext cx="3657600" cy="329184"/>
+            <a:ext cx="3840480" cy="329184"/>
           </a:xfrm>
           <a:prstGeom prst="rect">
             <a:avLst/>
@@ -5089,7 +5129,7 @@
                 <a:solidFill>
                   <a:srgbClr val="E2E8F0"/>
                 </a:solidFill>
-                <a:latin typeface="Segoe UI"/>
+                <a:latin typeface="Malgun Gothic"/>
               </a:defRPr>
             </a:pPr>
             <a:r>
@@ -5106,8 +5146,8 @@
         </p:nvSpPr>
         <p:spPr>
           <a:xfrm>
-            <a:off x="4480560" y="3438144"/>
-            <a:ext cx="1371600" cy="329184"/>
+            <a:off x="4663440" y="3438144"/>
+            <a:ext cx="1188720" cy="329184"/>
           </a:xfrm>
           <a:prstGeom prst="rect">
             <a:avLst/>
@@ -5125,11 +5165,11 @@
                 <a:solidFill>
                   <a:srgbClr val="FBBF24"/>
                 </a:solidFill>
-                <a:latin typeface="Segoe UI"/>
-              </a:defRPr>
-            </a:pPr>
-            <a:r>
-              <a:t>General</a:t>
+                <a:latin typeface="Malgun Gothic"/>
+              </a:defRPr>
+            </a:pPr>
+            <a:r>
+              <a:t>범용</a:t>
             </a:r>
           </a:p>
         </p:txBody>
@@ -5161,7 +5201,7 @@
                 <a:solidFill>
                   <a:srgbClr val="94A3B8"/>
                 </a:solidFill>
-                <a:latin typeface="Segoe UI"/>
+                <a:latin typeface="Malgun Gothic"/>
               </a:defRPr>
             </a:pPr>
             <a:r>
@@ -5197,7 +5237,7 @@
                 <a:solidFill>
                   <a:srgbClr val="FBBF24"/>
                 </a:solidFill>
-                <a:latin typeface="Segoe UI"/>
+                <a:latin typeface="Malgun Gothic"/>
               </a:defRPr>
             </a:pPr>
             <a:r>
@@ -5258,7 +5298,7 @@
         <p:spPr>
           <a:xfrm>
             <a:off x="822960" y="3767328"/>
-            <a:ext cx="3657600" cy="329184"/>
+            <a:ext cx="3840480" cy="329184"/>
           </a:xfrm>
           <a:prstGeom prst="rect">
             <a:avLst/>
@@ -5276,7 +5316,7 @@
                 <a:solidFill>
                   <a:srgbClr val="E2E8F0"/>
                 </a:solidFill>
-                <a:latin typeface="Segoe UI"/>
+                <a:latin typeface="Malgun Gothic"/>
               </a:defRPr>
             </a:pPr>
             <a:r>
@@ -5293,8 +5333,8 @@
         </p:nvSpPr>
         <p:spPr>
           <a:xfrm>
-            <a:off x="4480560" y="3767328"/>
-            <a:ext cx="1371600" cy="329184"/>
+            <a:off x="4663440" y="3767328"/>
+            <a:ext cx="1188720" cy="329184"/>
           </a:xfrm>
           <a:prstGeom prst="rect">
             <a:avLst/>
@@ -5312,11 +5352,11 @@
                 <a:solidFill>
                   <a:srgbClr val="FBBF24"/>
                 </a:solidFill>
-                <a:latin typeface="Segoe UI"/>
-              </a:defRPr>
-            </a:pPr>
-            <a:r>
-              <a:t>General</a:t>
+                <a:latin typeface="Malgun Gothic"/>
+              </a:defRPr>
+            </a:pPr>
+            <a:r>
+              <a:t>범용</a:t>
             </a:r>
           </a:p>
         </p:txBody>
@@ -5348,7 +5388,7 @@
                 <a:solidFill>
                   <a:srgbClr val="94A3B8"/>
                 </a:solidFill>
-                <a:latin typeface="Segoe UI"/>
+                <a:latin typeface="Malgun Gothic"/>
               </a:defRPr>
             </a:pPr>
             <a:r>
@@ -5384,7 +5424,7 @@
                 <a:solidFill>
                   <a:srgbClr val="FBBF24"/>
                 </a:solidFill>
-                <a:latin typeface="Segoe UI"/>
+                <a:latin typeface="Malgun Gothic"/>
               </a:defRPr>
             </a:pPr>
             <a:r>
@@ -5445,7 +5485,7 @@
         <p:spPr>
           <a:xfrm>
             <a:off x="822960" y="4096512"/>
-            <a:ext cx="3657600" cy="329184"/>
+            <a:ext cx="3840480" cy="329184"/>
           </a:xfrm>
           <a:prstGeom prst="rect">
             <a:avLst/>
@@ -5463,7 +5503,7 @@
                 <a:solidFill>
                   <a:srgbClr val="E2E8F0"/>
                 </a:solidFill>
-                <a:latin typeface="Segoe UI"/>
+                <a:latin typeface="Malgun Gothic"/>
               </a:defRPr>
             </a:pPr>
             <a:r>
@@ -5480,8 +5520,8 @@
         </p:nvSpPr>
         <p:spPr>
           <a:xfrm>
-            <a:off x="4480560" y="4096512"/>
-            <a:ext cx="1371600" cy="329184"/>
+            <a:off x="4663440" y="4096512"/>
+            <a:ext cx="1188720" cy="329184"/>
           </a:xfrm>
           <a:prstGeom prst="rect">
             <a:avLst/>
@@ -5499,11 +5539,11 @@
                 <a:solidFill>
                   <a:srgbClr val="4ADE80"/>
                 </a:solidFill>
-                <a:latin typeface="Segoe UI"/>
-              </a:defRPr>
-            </a:pPr>
-            <a:r>
-              <a:t>GUI-Trained</a:t>
+                <a:latin typeface="Malgun Gothic"/>
+              </a:defRPr>
+            </a:pPr>
+            <a:r>
+              <a:t>GUI 전용</a:t>
             </a:r>
           </a:p>
         </p:txBody>
@@ -5535,7 +5575,7 @@
                 <a:solidFill>
                   <a:srgbClr val="94A3B8"/>
                 </a:solidFill>
-                <a:latin typeface="Segoe UI"/>
+                <a:latin typeface="Malgun Gothic"/>
               </a:defRPr>
             </a:pPr>
             <a:r>
@@ -5571,7 +5611,7 @@
                 <a:solidFill>
                   <a:srgbClr val="FB923C"/>
                 </a:solidFill>
-                <a:latin typeface="Segoe UI"/>
+                <a:latin typeface="Malgun Gothic"/>
               </a:defRPr>
             </a:pPr>
             <a:r>
@@ -5632,7 +5672,7 @@
         <p:spPr>
           <a:xfrm>
             <a:off x="822960" y="4425696"/>
-            <a:ext cx="3657600" cy="329184"/>
+            <a:ext cx="3840480" cy="329184"/>
           </a:xfrm>
           <a:prstGeom prst="rect">
             <a:avLst/>
@@ -5650,7 +5690,7 @@
                 <a:solidFill>
                   <a:srgbClr val="E2E8F0"/>
                 </a:solidFill>
-                <a:latin typeface="Segoe UI"/>
+                <a:latin typeface="Malgun Gothic"/>
               </a:defRPr>
             </a:pPr>
             <a:r>
@@ -5667,8 +5707,8 @@
         </p:nvSpPr>
         <p:spPr>
           <a:xfrm>
-            <a:off x="4480560" y="4425696"/>
-            <a:ext cx="1371600" cy="329184"/>
+            <a:off x="4663440" y="4425696"/>
+            <a:ext cx="1188720" cy="329184"/>
           </a:xfrm>
           <a:prstGeom prst="rect">
             <a:avLst/>
@@ -5686,11 +5726,11 @@
                 <a:solidFill>
                   <a:srgbClr val="4ADE80"/>
                 </a:solidFill>
-                <a:latin typeface="Segoe UI"/>
-              </a:defRPr>
-            </a:pPr>
-            <a:r>
-              <a:t>GUI-Trained</a:t>
+                <a:latin typeface="Malgun Gothic"/>
+              </a:defRPr>
+            </a:pPr>
+            <a:r>
+              <a:t>GUI 전용</a:t>
             </a:r>
           </a:p>
         </p:txBody>
@@ -5722,7 +5762,7 @@
                 <a:solidFill>
                   <a:srgbClr val="94A3B8"/>
                 </a:solidFill>
-                <a:latin typeface="Segoe UI"/>
+                <a:latin typeface="Malgun Gothic"/>
               </a:defRPr>
             </a:pPr>
             <a:r>
@@ -5758,7 +5798,7 @@
                 <a:solidFill>
                   <a:srgbClr val="FB923C"/>
                 </a:solidFill>
-                <a:latin typeface="Segoe UI"/>
+                <a:latin typeface="Malgun Gothic"/>
               </a:defRPr>
             </a:pPr>
             <a:r>
@@ -5819,7 +5859,7 @@
         <p:spPr>
           <a:xfrm>
             <a:off x="822960" y="4754879"/>
-            <a:ext cx="3657600" cy="329184"/>
+            <a:ext cx="3840480" cy="329184"/>
           </a:xfrm>
           <a:prstGeom prst="rect">
             <a:avLst/>
@@ -5837,11 +5877,11 @@
                 <a:solidFill>
                   <a:srgbClr val="F87171"/>
                 </a:solidFill>
-                <a:latin typeface="Segoe UI"/>
-              </a:defRPr>
-            </a:pPr>
-            <a:r>
-              <a:t>Kimi-VL / MoonViT (CURRENT)</a:t>
+                <a:latin typeface="Malgun Gothic"/>
+              </a:defRPr>
+            </a:pPr>
+            <a:r>
+              <a:t>Kimi-VL / MoonViT (현재 운영 중)</a:t>
             </a:r>
           </a:p>
         </p:txBody>
@@ -5854,8 +5894,8 @@
         </p:nvSpPr>
         <p:spPr>
           <a:xfrm>
-            <a:off x="4480560" y="4754879"/>
-            <a:ext cx="1371600" cy="329184"/>
+            <a:off x="4663440" y="4754879"/>
+            <a:ext cx="1188720" cy="329184"/>
           </a:xfrm>
           <a:prstGeom prst="rect">
             <a:avLst/>
@@ -5873,11 +5913,11 @@
                 <a:solidFill>
                   <a:srgbClr val="FBBF24"/>
                 </a:solidFill>
-                <a:latin typeface="Segoe UI"/>
-              </a:defRPr>
-            </a:pPr>
-            <a:r>
-              <a:t>General</a:t>
+                <a:latin typeface="Malgun Gothic"/>
+              </a:defRPr>
+            </a:pPr>
+            <a:r>
+              <a:t>범용</a:t>
             </a:r>
           </a:p>
         </p:txBody>
@@ -5909,7 +5949,7 @@
                 <a:solidFill>
                   <a:srgbClr val="94A3B8"/>
                 </a:solidFill>
-                <a:latin typeface="Segoe UI"/>
+                <a:latin typeface="Malgun Gothic"/>
               </a:defRPr>
             </a:pPr>
             <a:r>
@@ -5945,7 +5985,7 @@
                 <a:solidFill>
                   <a:srgbClr val="F87171"/>
                 </a:solidFill>
-                <a:latin typeface="Segoe UI"/>
+                <a:latin typeface="Malgun Gothic"/>
               </a:defRPr>
             </a:pPr>
             <a:r>
@@ -6006,7 +6046,7 @@
         <p:spPr>
           <a:xfrm>
             <a:off x="822960" y="5084064"/>
-            <a:ext cx="3657600" cy="329184"/>
+            <a:ext cx="3840480" cy="329184"/>
           </a:xfrm>
           <a:prstGeom prst="rect">
             <a:avLst/>
@@ -6024,7 +6064,7 @@
                 <a:solidFill>
                   <a:srgbClr val="E2E8F0"/>
                 </a:solidFill>
-                <a:latin typeface="Segoe UI"/>
+                <a:latin typeface="Malgun Gothic"/>
               </a:defRPr>
             </a:pPr>
             <a:r>
@@ -6041,8 +6081,8 @@
         </p:nvSpPr>
         <p:spPr>
           <a:xfrm>
-            <a:off x="4480560" y="5084064"/>
-            <a:ext cx="1371600" cy="329184"/>
+            <a:off x="4663440" y="5084064"/>
+            <a:ext cx="1188720" cy="329184"/>
           </a:xfrm>
           <a:prstGeom prst="rect">
             <a:avLst/>
@@ -6060,11 +6100,11 @@
                 <a:solidFill>
                   <a:srgbClr val="4ADE80"/>
                 </a:solidFill>
-                <a:latin typeface="Segoe UI"/>
-              </a:defRPr>
-            </a:pPr>
-            <a:r>
-              <a:t>GUI-Trained</a:t>
+                <a:latin typeface="Malgun Gothic"/>
+              </a:defRPr>
+            </a:pPr>
+            <a:r>
+              <a:t>GUI 전용</a:t>
             </a:r>
           </a:p>
         </p:txBody>
@@ -6096,7 +6136,7 @@
                 <a:solidFill>
                   <a:srgbClr val="94A3B8"/>
                 </a:solidFill>
-                <a:latin typeface="Segoe UI"/>
+                <a:latin typeface="Malgun Gothic"/>
               </a:defRPr>
             </a:pPr>
             <a:r>
@@ -6132,7 +6172,7 @@
                 <a:solidFill>
                   <a:srgbClr val="F87171"/>
                 </a:solidFill>
-                <a:latin typeface="Segoe UI"/>
+                <a:latin typeface="Malgun Gothic"/>
               </a:defRPr>
             </a:pPr>
             <a:r>
@@ -6193,7 +6233,7 @@
         <p:spPr>
           <a:xfrm>
             <a:off x="822960" y="5413248"/>
-            <a:ext cx="3657600" cy="329184"/>
+            <a:ext cx="3840480" cy="329184"/>
           </a:xfrm>
           <a:prstGeom prst="rect">
             <a:avLst/>
@@ -6211,7 +6251,7 @@
                 <a:solidFill>
                   <a:srgbClr val="E2E8F0"/>
                 </a:solidFill>
-                <a:latin typeface="Segoe UI"/>
+                <a:latin typeface="Malgun Gothic"/>
               </a:defRPr>
             </a:pPr>
             <a:r>
@@ -6228,8 +6268,8 @@
         </p:nvSpPr>
         <p:spPr>
           <a:xfrm>
-            <a:off x="4480560" y="5413248"/>
-            <a:ext cx="1371600" cy="329184"/>
+            <a:off x="4663440" y="5413248"/>
+            <a:ext cx="1188720" cy="329184"/>
           </a:xfrm>
           <a:prstGeom prst="rect">
             <a:avLst/>
@@ -6247,11 +6287,11 @@
                 <a:solidFill>
                   <a:srgbClr val="FBBF24"/>
                 </a:solidFill>
-                <a:latin typeface="Segoe UI"/>
-              </a:defRPr>
-            </a:pPr>
-            <a:r>
-              <a:t>General</a:t>
+                <a:latin typeface="Malgun Gothic"/>
+              </a:defRPr>
+            </a:pPr>
+            <a:r>
+              <a:t>범용</a:t>
             </a:r>
           </a:p>
         </p:txBody>
@@ -6283,7 +6323,7 @@
                 <a:solidFill>
                   <a:srgbClr val="94A3B8"/>
                 </a:solidFill>
-                <a:latin typeface="Segoe UI"/>
+                <a:latin typeface="Malgun Gothic"/>
               </a:defRPr>
             </a:pPr>
             <a:r>
@@ -6319,7 +6359,7 @@
                 <a:solidFill>
                   <a:srgbClr val="F87171"/>
                 </a:solidFill>
-                <a:latin typeface="Segoe UI"/>
+                <a:latin typeface="Malgun Gothic"/>
               </a:defRPr>
             </a:pPr>
             <a:r>
@@ -6380,7 +6420,7 @@
         <p:spPr>
           <a:xfrm>
             <a:off x="822960" y="5742431"/>
-            <a:ext cx="3657600" cy="329184"/>
+            <a:ext cx="3840480" cy="329184"/>
           </a:xfrm>
           <a:prstGeom prst="rect">
             <a:avLst/>
@@ -6398,7 +6438,7 @@
                 <a:solidFill>
                   <a:srgbClr val="E2E8F0"/>
                 </a:solidFill>
-                <a:latin typeface="Segoe UI"/>
+                <a:latin typeface="Malgun Gothic"/>
               </a:defRPr>
             </a:pPr>
             <a:r>
@@ -6415,8 +6455,8 @@
         </p:nvSpPr>
         <p:spPr>
           <a:xfrm>
-            <a:off x="4480560" y="5742431"/>
-            <a:ext cx="1371600" cy="329184"/>
+            <a:off x="4663440" y="5742431"/>
+            <a:ext cx="1188720" cy="329184"/>
           </a:xfrm>
           <a:prstGeom prst="rect">
             <a:avLst/>
@@ -6434,11 +6474,11 @@
                 <a:solidFill>
                   <a:srgbClr val="FBBF24"/>
                 </a:solidFill>
-                <a:latin typeface="Segoe UI"/>
-              </a:defRPr>
-            </a:pPr>
-            <a:r>
-              <a:t>General</a:t>
+                <a:latin typeface="Malgun Gothic"/>
+              </a:defRPr>
+            </a:pPr>
+            <a:r>
+              <a:t>범용</a:t>
             </a:r>
           </a:p>
         </p:txBody>
@@ -6470,7 +6510,7 @@
                 <a:solidFill>
                   <a:srgbClr val="94A3B8"/>
                 </a:solidFill>
-                <a:latin typeface="Segoe UI"/>
+                <a:latin typeface="Malgun Gothic"/>
               </a:defRPr>
             </a:pPr>
             <a:r>
@@ -6506,7 +6546,7 @@
                 <a:solidFill>
                   <a:srgbClr val="F87171"/>
                 </a:solidFill>
-                <a:latin typeface="Segoe UI"/>
+                <a:latin typeface="Malgun Gothic"/>
               </a:defRPr>
             </a:pPr>
             <a:r>
@@ -6587,11 +6627,11 @@
                 <a:solidFill>
                   <a:srgbClr val="F87171"/>
                 </a:solidFill>
-                <a:latin typeface="Segoe UI"/>
-              </a:defRPr>
-            </a:pPr>
-            <a:r>
-              <a:t>Key Insight</a:t>
+                <a:latin typeface="Malgun Gothic"/>
+              </a:defRPr>
+            </a:pPr>
+            <a:r>
+              <a:t>핵심 수치</a:t>
             </a:r>
           </a:p>
         </p:txBody>
@@ -6626,11 +6666,11 @@
                 <a:solidFill>
                   <a:srgbClr val="94A3B8"/>
                 </a:solidFill>
-                <a:latin typeface="Segoe UI"/>
-              </a:defRPr>
-            </a:pPr>
-            <a:r>
-              <a:t>Kimi-VL: 34.5%</a:t>
+                <a:latin typeface="Malgun Gothic"/>
+              </a:defRPr>
+            </a:pPr>
+            <a:r>
+              <a:t>현재 Kimi-VL: 34.5%</a:t>
             </a:r>
           </a:p>
           <a:p>
@@ -6642,7 +6682,7 @@
                 <a:solidFill>
                   <a:srgbClr val="94A3B8"/>
                 </a:solidFill>
-                <a:latin typeface="Segoe UI"/>
+                <a:latin typeface="Malgun Gothic"/>
               </a:defRPr>
             </a:pPr>
             <a:r>
@@ -6658,7 +6698,7 @@
                 <a:solidFill>
                   <a:srgbClr val="94A3B8"/>
                 </a:solidFill>
-                <a:latin typeface="Segoe UI"/>
+                <a:latin typeface="Malgun Gothic"/>
               </a:defRPr>
             </a:pPr>
           </a:p>
@@ -6671,11 +6711,11 @@
                 <a:solidFill>
                   <a:srgbClr val="94A3B8"/>
                 </a:solidFill>
-                <a:latin typeface="Segoe UI"/>
-              </a:defRPr>
-            </a:pPr>
-            <a:r>
-              <a:t>+78% improvement</a:t>
+                <a:latin typeface="Malgun Gothic"/>
+              </a:defRPr>
+            </a:pPr>
+            <a:r>
+              <a:t>+78% 정확도 향상</a:t>
             </a:r>
           </a:p>
           <a:p>
@@ -6687,11 +6727,11 @@
                 <a:solidFill>
                   <a:srgbClr val="94A3B8"/>
                 </a:solidFill>
-                <a:latin typeface="Segoe UI"/>
-              </a:defRPr>
-            </a:pPr>
-            <a:r>
-              <a:t>with a 7B model</a:t>
+                <a:latin typeface="Malgun Gothic"/>
+              </a:defRPr>
+            </a:pPr>
+            <a:r>
+              <a:t>(7B 모델로 달성 가능)</a:t>
             </a:r>
           </a:p>
           <a:p>
@@ -6703,7 +6743,7 @@
                 <a:solidFill>
                   <a:srgbClr val="94A3B8"/>
                 </a:solidFill>
-                <a:latin typeface="Segoe UI"/>
+                <a:latin typeface="Malgun Gothic"/>
               </a:defRPr>
             </a:pPr>
           </a:p>
@@ -6716,11 +6756,11 @@
                 <a:solidFill>
                   <a:srgbClr val="94A3B8"/>
                 </a:solidFill>
-                <a:latin typeface="Segoe UI"/>
-              </a:defRPr>
-            </a:pPr>
-            <a:r>
-              <a:t>GUI-trained 7B models</a:t>
+                <a:latin typeface="Malgun Gothic"/>
+              </a:defRPr>
+            </a:pPr>
+            <a:r>
+              <a:t>GUI 전용 7B 모델이</a:t>
             </a:r>
           </a:p>
           <a:p>
@@ -6732,11 +6772,11 @@
                 <a:solidFill>
                   <a:srgbClr val="94A3B8"/>
                 </a:solidFill>
-                <a:latin typeface="Segoe UI"/>
-              </a:defRPr>
-            </a:pPr>
-            <a:r>
-              <a:t>outperform general</a:t>
+                <a:latin typeface="Malgun Gothic"/>
+              </a:defRPr>
+            </a:pPr>
+            <a:r>
+              <a:t>범용 200B+ 모델보다</a:t>
             </a:r>
           </a:p>
           <a:p>
@@ -6748,11 +6788,11 @@
                 <a:solidFill>
                   <a:srgbClr val="94A3B8"/>
                 </a:solidFill>
-                <a:latin typeface="Segoe UI"/>
-              </a:defRPr>
-            </a:pPr>
-            <a:r>
-              <a:t>200B+ models on</a:t>
+                <a:latin typeface="Malgun Gothic"/>
+              </a:defRPr>
+            </a:pPr>
+            <a:r>
+              <a:t>전문 UI에서 월등히 우수</a:t>
             </a:r>
           </a:p>
           <a:p>
@@ -6764,11 +6804,40 @@
                 <a:solidFill>
                   <a:srgbClr val="94A3B8"/>
                 </a:solidFill>
-                <a:latin typeface="Segoe UI"/>
-              </a:defRPr>
-            </a:pPr>
-            <a:r>
-              <a:t>professional UIs</a:t>
+                <a:latin typeface="Malgun Gothic"/>
+              </a:defRPr>
+            </a:pPr>
+          </a:p>
+          <a:p>
+            <a:pPr>
+              <a:spcAft>
+                <a:spcPts val="400"/>
+              </a:spcAft>
+              <a:defRPr sz="1100">
+                <a:solidFill>
+                  <a:srgbClr val="94A3B8"/>
+                </a:solidFill>
+                <a:latin typeface="Malgun Gothic"/>
+              </a:defRPr>
+            </a:pPr>
+            <a:r>
+              <a:t>→ 전용 모델 + 전용 GPU</a:t>
+            </a:r>
+          </a:p>
+          <a:p>
+            <a:pPr>
+              <a:spcAft>
+                <a:spcPts val="400"/>
+              </a:spcAft>
+              <a:defRPr sz="1100">
+                <a:solidFill>
+                  <a:srgbClr val="94A3B8"/>
+                </a:solidFill>
+                <a:latin typeface="Malgun Gothic"/>
+              </a:defRPr>
+            </a:pPr>
+            <a:r>
+              <a:t>   가 해답</a:t>
             </a:r>
           </a:p>
         </p:txBody>
@@ -6826,11 +6895,11 @@
                 <a:solidFill>
                   <a:srgbClr val="38BDF8"/>
                 </a:solidFill>
-                <a:latin typeface="Segoe UI"/>
-              </a:defRPr>
-            </a:pPr>
-            <a:r>
-              <a:t>End-to-End Agent Benchmarks: Multi-Step Desktop Automation</a:t>
+                <a:latin typeface="Malgun Gothic"/>
+              </a:defRPr>
+            </a:pPr>
+            <a:r>
+              <a:t>End-to-End Agent 벤치마크: 다단계 데스크톱 자동화</a:t>
             </a:r>
           </a:p>
         </p:txBody>
@@ -6862,11 +6931,11 @@
                 <a:solidFill>
                   <a:srgbClr val="94A3B8"/>
                 </a:solidFill>
-                <a:latin typeface="Segoe UI"/>
-              </a:defRPr>
-            </a:pPr>
-            <a:r>
-              <a:t>OSWorld &amp; WindowsAgentArena directly test Windows desktop automation — same environment as RCS/CD-SEM</a:t>
+                <a:latin typeface="Malgun Gothic"/>
+              </a:defRPr>
+            </a:pPr>
+            <a:r>
+              <a:t>OSWorld &amp; WindowsAgentArena = Windows 데스크톱 자동화 직접 테스트 — RCS/CD-SEM과 동일한 환경</a:t>
             </a:r>
           </a:p>
         </p:txBody>
@@ -6941,11 +7010,11 @@
                 <a:solidFill>
                   <a:srgbClr val="38BDF8"/>
                 </a:solidFill>
-                <a:latin typeface="Segoe UI"/>
-              </a:defRPr>
-            </a:pPr>
-            <a:r>
-              <a:t>Model</a:t>
+                <a:latin typeface="Malgun Gothic"/>
+              </a:defRPr>
+            </a:pPr>
+            <a:r>
+              <a:t>모델</a:t>
             </a:r>
           </a:p>
         </p:txBody>
@@ -6977,7 +7046,7 @@
                 <a:solidFill>
                   <a:srgbClr val="38BDF8"/>
                 </a:solidFill>
-                <a:latin typeface="Segoe UI"/>
+                <a:latin typeface="Malgun Gothic"/>
               </a:defRPr>
             </a:pPr>
             <a:r>
@@ -7013,7 +7082,7 @@
                 <a:solidFill>
                   <a:srgbClr val="38BDF8"/>
                 </a:solidFill>
-                <a:latin typeface="Segoe UI"/>
+                <a:latin typeface="Malgun Gothic"/>
               </a:defRPr>
             </a:pPr>
             <a:r>
@@ -7049,7 +7118,7 @@
                 <a:solidFill>
                   <a:srgbClr val="38BDF8"/>
                 </a:solidFill>
-                <a:latin typeface="Segoe UI"/>
+                <a:latin typeface="Malgun Gothic"/>
               </a:defRPr>
             </a:pPr>
             <a:r>
@@ -7085,7 +7154,7 @@
                 <a:solidFill>
                   <a:srgbClr val="38BDF8"/>
                 </a:solidFill>
-                <a:latin typeface="Segoe UI"/>
+                <a:latin typeface="Malgun Gothic"/>
               </a:defRPr>
             </a:pPr>
             <a:r>
@@ -7164,7 +7233,7 @@
                 <a:solidFill>
                   <a:srgbClr val="E2E8F0"/>
                 </a:solidFill>
-                <a:latin typeface="Segoe UI"/>
+                <a:latin typeface="Malgun Gothic"/>
               </a:defRPr>
             </a:pPr>
             <a:r>
@@ -7200,7 +7269,7 @@
                 <a:solidFill>
                   <a:srgbClr val="4ADE80"/>
                 </a:solidFill>
-                <a:latin typeface="Segoe UI"/>
+                <a:latin typeface="Malgun Gothic"/>
               </a:defRPr>
             </a:pPr>
             <a:r>
@@ -7236,7 +7305,7 @@
                 <a:solidFill>
                   <a:srgbClr val="4ADE80"/>
                 </a:solidFill>
-                <a:latin typeface="Segoe UI"/>
+                <a:latin typeface="Malgun Gothic"/>
               </a:defRPr>
             </a:pPr>
             <a:r>
@@ -7272,7 +7341,7 @@
                 <a:solidFill>
                   <a:srgbClr val="4ADE80"/>
                 </a:solidFill>
-                <a:latin typeface="Segoe UI"/>
+                <a:latin typeface="Malgun Gothic"/>
               </a:defRPr>
             </a:pPr>
             <a:r>
@@ -7308,7 +7377,7 @@
                 <a:solidFill>
                   <a:srgbClr val="4ADE80"/>
                 </a:solidFill>
-                <a:latin typeface="Segoe UI"/>
+                <a:latin typeface="Malgun Gothic"/>
               </a:defRPr>
             </a:pPr>
             <a:r>
@@ -7387,7 +7456,7 @@
                 <a:solidFill>
                   <a:srgbClr val="E2E8F0"/>
                 </a:solidFill>
-                <a:latin typeface="Segoe UI"/>
+                <a:latin typeface="Malgun Gothic"/>
               </a:defRPr>
             </a:pPr>
             <a:r>
@@ -7423,7 +7492,7 @@
                 <a:solidFill>
                   <a:srgbClr val="38BDF8"/>
                 </a:solidFill>
-                <a:latin typeface="Segoe UI"/>
+                <a:latin typeface="Malgun Gothic"/>
               </a:defRPr>
             </a:pPr>
             <a:r>
@@ -7459,7 +7528,7 @@
                 <a:solidFill>
                   <a:srgbClr val="94A3B8"/>
                 </a:solidFill>
-                <a:latin typeface="Segoe UI"/>
+                <a:latin typeface="Malgun Gothic"/>
               </a:defRPr>
             </a:pPr>
             <a:r>
@@ -7495,7 +7564,7 @@
                 <a:solidFill>
                   <a:srgbClr val="94A3B8"/>
                 </a:solidFill>
-                <a:latin typeface="Segoe UI"/>
+                <a:latin typeface="Malgun Gothic"/>
               </a:defRPr>
             </a:pPr>
             <a:r>
@@ -7531,7 +7600,7 @@
                 <a:solidFill>
                   <a:srgbClr val="94A3B8"/>
                 </a:solidFill>
-                <a:latin typeface="Segoe UI"/>
+                <a:latin typeface="Malgun Gothic"/>
               </a:defRPr>
             </a:pPr>
             <a:r>
@@ -7610,7 +7679,7 @@
                 <a:solidFill>
                   <a:srgbClr val="E2E8F0"/>
                 </a:solidFill>
-                <a:latin typeface="Segoe UI"/>
+                <a:latin typeface="Malgun Gothic"/>
               </a:defRPr>
             </a:pPr>
             <a:r>
@@ -7646,7 +7715,7 @@
                 <a:solidFill>
                   <a:srgbClr val="38BDF8"/>
                 </a:solidFill>
-                <a:latin typeface="Segoe UI"/>
+                <a:latin typeface="Malgun Gothic"/>
               </a:defRPr>
             </a:pPr>
             <a:r>
@@ -7682,7 +7751,7 @@
                 <a:solidFill>
                   <a:srgbClr val="94A3B8"/>
                 </a:solidFill>
-                <a:latin typeface="Segoe UI"/>
+                <a:latin typeface="Malgun Gothic"/>
               </a:defRPr>
             </a:pPr>
             <a:r>
@@ -7718,7 +7787,7 @@
                 <a:solidFill>
                   <a:srgbClr val="4ADE80"/>
                 </a:solidFill>
-                <a:latin typeface="Segoe UI"/>
+                <a:latin typeface="Malgun Gothic"/>
               </a:defRPr>
             </a:pPr>
             <a:r>
@@ -7754,7 +7823,7 @@
                 <a:solidFill>
                   <a:srgbClr val="4ADE80"/>
                 </a:solidFill>
-                <a:latin typeface="Segoe UI"/>
+                <a:latin typeface="Malgun Gothic"/>
               </a:defRPr>
             </a:pPr>
             <a:r>
@@ -7833,7 +7902,7 @@
                 <a:solidFill>
                   <a:srgbClr val="E2E8F0"/>
                 </a:solidFill>
-                <a:latin typeface="Segoe UI"/>
+                <a:latin typeface="Malgun Gothic"/>
               </a:defRPr>
             </a:pPr>
             <a:r>
@@ -7869,7 +7938,7 @@
                 <a:solidFill>
                   <a:srgbClr val="38BDF8"/>
                 </a:solidFill>
-                <a:latin typeface="Segoe UI"/>
+                <a:latin typeface="Malgun Gothic"/>
               </a:defRPr>
             </a:pPr>
             <a:r>
@@ -7905,7 +7974,7 @@
                 <a:solidFill>
                   <a:srgbClr val="38BDF8"/>
                 </a:solidFill>
-                <a:latin typeface="Segoe UI"/>
+                <a:latin typeface="Malgun Gothic"/>
               </a:defRPr>
             </a:pPr>
             <a:r>
@@ -7941,7 +8010,7 @@
                 <a:solidFill>
                   <a:srgbClr val="4ADE80"/>
                 </a:solidFill>
-                <a:latin typeface="Segoe UI"/>
+                <a:latin typeface="Malgun Gothic"/>
               </a:defRPr>
             </a:pPr>
             <a:r>
@@ -7977,7 +8046,7 @@
                 <a:solidFill>
                   <a:srgbClr val="4ADE80"/>
                 </a:solidFill>
-                <a:latin typeface="Segoe UI"/>
+                <a:latin typeface="Malgun Gothic"/>
               </a:defRPr>
             </a:pPr>
             <a:r>
@@ -8056,7 +8125,7 @@
                 <a:solidFill>
                   <a:srgbClr val="E2E8F0"/>
                 </a:solidFill>
-                <a:latin typeface="Segoe UI"/>
+                <a:latin typeface="Malgun Gothic"/>
               </a:defRPr>
             </a:pPr>
             <a:r>
@@ -8092,7 +8161,7 @@
                 <a:solidFill>
                   <a:srgbClr val="94A3B8"/>
                 </a:solidFill>
-                <a:latin typeface="Segoe UI"/>
+                <a:latin typeface="Malgun Gothic"/>
               </a:defRPr>
             </a:pPr>
             <a:r>
@@ -8128,7 +8197,7 @@
                 <a:solidFill>
                   <a:srgbClr val="94A3B8"/>
                 </a:solidFill>
-                <a:latin typeface="Segoe UI"/>
+                <a:latin typeface="Malgun Gothic"/>
               </a:defRPr>
             </a:pPr>
             <a:r>
@@ -8164,7 +8233,7 @@
                 <a:solidFill>
                   <a:srgbClr val="4ADE80"/>
                 </a:solidFill>
-                <a:latin typeface="Segoe UI"/>
+                <a:latin typeface="Malgun Gothic"/>
               </a:defRPr>
             </a:pPr>
             <a:r>
@@ -8200,7 +8269,7 @@
                 <a:solidFill>
                   <a:srgbClr val="94A3B8"/>
                 </a:solidFill>
-                <a:latin typeface="Segoe UI"/>
+                <a:latin typeface="Malgun Gothic"/>
               </a:defRPr>
             </a:pPr>
             <a:r>
@@ -8281,11 +8350,11 @@
                 <a:solidFill>
                   <a:srgbClr val="38BDF8"/>
                 </a:solidFill>
-                <a:latin typeface="Segoe UI"/>
-              </a:defRPr>
-            </a:pPr>
-            <a:r>
-              <a:t>Why This Matters for RCS Automation</a:t>
+                <a:latin typeface="Malgun Gothic"/>
+              </a:defRPr>
+            </a:pPr>
+            <a:r>
+              <a:t>RCS 자동화에 왜 중요한가</a:t>
             </a:r>
           </a:p>
         </p:txBody>
@@ -8320,11 +8389,11 @@
                 <a:solidFill>
                   <a:srgbClr val="94A3B8"/>
                 </a:solidFill>
-                <a:latin typeface="Segoe UI"/>
-              </a:defRPr>
-            </a:pPr>
-            <a:r>
-              <a:t>  UI-TARS-2 leads both OSWorld (47.5%) and WindowsAgentArena (50.6%) — direct Windows desktop benchmarks</a:t>
+                <a:latin typeface="Malgun Gothic"/>
+              </a:defRPr>
+            </a:pPr>
+            <a:r>
+              <a:t>  UI-TARS-2가 OSWorld (47.5%) / WindowsAgentArena (50.6%) 모두 1위 — Windows 데스크톱 자동화 직접 벤치마크</a:t>
             </a:r>
           </a:p>
           <a:p>
@@ -8336,11 +8405,11 @@
                 <a:solidFill>
                   <a:srgbClr val="94A3B8"/>
                 </a:solidFill>
-                <a:latin typeface="Segoe UI"/>
-              </a:defRPr>
-            </a:pPr>
-            <a:r>
-              <a:t>  These models can autonomously navigate complex multi-step workflows: launch app → find controls → click → type → verify</a:t>
+                <a:latin typeface="Malgun Gothic"/>
+              </a:defRPr>
+            </a:pPr>
+            <a:r>
+              <a:t>  이 모델들은 복잡한 다단계 워크플로우를 자율 수행: 앱 실행 → 컨트롤 탐색 → 클릭 → 입력 → 검증</a:t>
             </a:r>
           </a:p>
           <a:p>
@@ -8352,11 +8421,11 @@
                 <a:solidFill>
                   <a:srgbClr val="94A3B8"/>
                 </a:solidFill>
-                <a:latin typeface="Segoe UI"/>
-              </a:defRPr>
-            </a:pPr>
-            <a:r>
-              <a:t>  Exactly the capability needed for RCS recipe creation: login → switch tabs → select tools → configure parameters</a:t>
+                <a:latin typeface="Malgun Gothic"/>
+              </a:defRPr>
+            </a:pPr>
+            <a:r>
+              <a:t>  RCS 레시피 생성에 필요한 능력과 정확히 일치: 로그인 → 탭 전환 → 도구 선택 → 파라미터 설정</a:t>
             </a:r>
           </a:p>
           <a:p>
@@ -8368,11 +8437,11 @@
                 <a:solidFill>
                   <a:srgbClr val="94A3B8"/>
                 </a:solidFill>
-                <a:latin typeface="Segoe UI"/>
-              </a:defRPr>
-            </a:pPr>
-            <a:r>
-              <a:t>  Open-source &amp; self-hostable via vLLM — no API cost, no vendor dependency, full data privacy</a:t>
+                <a:latin typeface="Malgun Gothic"/>
+              </a:defRPr>
+            </a:pPr>
+            <a:r>
+              <a:t>  오픈소스 &amp; vLLM 셀프 호스팅 가능 — 현재 Kimi 사내 서버와 독립적으로 운영 가능</a:t>
             </a:r>
           </a:p>
         </p:txBody>
@@ -8430,25 +8499,61 @@
                 <a:solidFill>
                   <a:srgbClr val="38BDF8"/>
                 </a:solidFill>
-                <a:latin typeface="Segoe UI"/>
-              </a:defRPr>
-            </a:pPr>
-            <a:r>
-              <a:t>GPU Resource Requirement: H200 x 2</a:t>
-            </a:r>
-          </a:p>
-        </p:txBody>
-      </p:sp>
-      <p:sp>
-        <p:nvSpPr>
-          <p:cNvPr id="3" name="Rounded Rectangle 2"/>
+                <a:latin typeface="Malgun Gothic"/>
+              </a:defRPr>
+            </a:pPr>
+            <a:r>
+              <a:t>GPU 리소스 요구사항: H200 x 2 도입 근거</a:t>
+            </a:r>
+          </a:p>
+        </p:txBody>
+      </p:sp>
+      <p:sp>
+        <p:nvSpPr>
+          <p:cNvPr id="3" name="TextBox 2"/>
+          <p:cNvSpPr txBox="1"/>
+          <p:nvPr/>
+        </p:nvSpPr>
+        <p:spPr>
+          <a:xfrm>
+            <a:off x="731520" y="868680"/>
+            <a:ext cx="10058400" cy="365760"/>
+          </a:xfrm>
+          <a:prstGeom prst="rect">
+            <a:avLst/>
+          </a:prstGeom>
+          <a:noFill/>
+        </p:spPr>
+        <p:txBody>
+          <a:bodyPr wrap="square">
+            <a:spAutoFit/>
+          </a:bodyPr>
+          <a:lstStyle/>
+          <a:p>
+            <a:pPr algn="l">
+              <a:defRPr sz="1300" b="0">
+                <a:solidFill>
+                  <a:srgbClr val="FBBF24"/>
+                </a:solidFill>
+                <a:latin typeface="Malgun Gothic"/>
+              </a:defRPr>
+            </a:pPr>
+            <a:r>
+              <a:t>기존 Kimi-VL 사내 서버와 별도로, GUI 자동화 전용 모델을 위한 독립 GPU 인프라 필요</a:t>
+            </a:r>
+          </a:p>
+        </p:txBody>
+      </p:sp>
+      <p:sp>
+        <p:nvSpPr>
+          <p:cNvPr id="4" name="Rounded Rectangle 3"/>
           <p:cNvSpPr/>
           <p:nvPr/>
         </p:nvSpPr>
         <p:spPr>
           <a:xfrm>
-            <a:off x="731520" y="1188720"/>
-            <a:ext cx="5303520" cy="2286000"/>
+            <a:off x="731520" y="1371600"/>
+            <a:ext cx="5303520" cy="2103120"/>
           </a:xfrm>
           <a:prstGeom prst="roundRect">
             <a:avLst/>
@@ -8486,13 +8591,13 @@
       </p:sp>
       <p:sp>
         <p:nvSpPr>
-          <p:cNvPr id="4" name="TextBox 3"/>
-          <p:cNvSpPr txBox="1"/>
-          <p:nvPr/>
-        </p:nvSpPr>
-        <p:spPr>
-          <a:xfrm>
-            <a:off x="914400" y="1280160"/>
+          <p:cNvPr id="5" name="TextBox 4"/>
+          <p:cNvSpPr txBox="1"/>
+          <p:nvPr/>
+        </p:nvSpPr>
+        <p:spPr>
+          <a:xfrm>
+            <a:off x="914400" y="1417320"/>
             <a:ext cx="4937760" cy="365760"/>
           </a:xfrm>
           <a:prstGeom prst="rect">
@@ -8511,25 +8616,25 @@
                 <a:solidFill>
                   <a:srgbClr val="38BDF8"/>
                 </a:solidFill>
-                <a:latin typeface="Segoe UI"/>
-              </a:defRPr>
-            </a:pPr>
-            <a:r>
-              <a:t>NVIDIA H200 SXM Specifications</a:t>
-            </a:r>
-          </a:p>
-        </p:txBody>
-      </p:sp>
-      <p:sp>
-        <p:nvSpPr>
-          <p:cNvPr id="5" name="TextBox 4"/>
-          <p:cNvSpPr txBox="1"/>
-          <p:nvPr/>
-        </p:nvSpPr>
-        <p:spPr>
-          <a:xfrm>
-            <a:off x="914400" y="1737360"/>
-            <a:ext cx="4937760" cy="1645920"/>
+                <a:latin typeface="Malgun Gothic"/>
+              </a:defRPr>
+            </a:pPr>
+            <a:r>
+              <a:t>NVIDIA H200 SXM 사양</a:t>
+            </a:r>
+          </a:p>
+        </p:txBody>
+      </p:sp>
+      <p:sp>
+        <p:nvSpPr>
+          <p:cNvPr id="6" name="TextBox 5"/>
+          <p:cNvSpPr txBox="1"/>
+          <p:nvPr/>
+        </p:nvSpPr>
+        <p:spPr>
+          <a:xfrm>
+            <a:off x="914400" y="1828800"/>
+            <a:ext cx="4937760" cy="1463040"/>
           </a:xfrm>
           <a:prstGeom prst="rect">
             <a:avLst/>
@@ -8550,11 +8655,11 @@
                 <a:solidFill>
                   <a:srgbClr val="94A3B8"/>
                 </a:solidFill>
-                <a:latin typeface="Segoe UI"/>
-              </a:defRPr>
-            </a:pPr>
-            <a:r>
-              <a:t>  HBM3e Memory: 141 GB per GPU</a:t>
+                <a:latin typeface="Malgun Gothic"/>
+              </a:defRPr>
+            </a:pPr>
+            <a:r>
+              <a:t>  HBM3e 메모리: GPU당 141 GB</a:t>
             </a:r>
           </a:p>
           <a:p>
@@ -8566,11 +8671,11 @@
                 <a:solidFill>
                   <a:srgbClr val="94A3B8"/>
                 </a:solidFill>
-                <a:latin typeface="Segoe UI"/>
-              </a:defRPr>
-            </a:pPr>
-            <a:r>
-              <a:t>  Memory Bandwidth: 4.8 TB/s</a:t>
+                <a:latin typeface="Malgun Gothic"/>
+              </a:defRPr>
+            </a:pPr>
+            <a:r>
+              <a:t>  메모리 대역폭: 4.8 TB/s</a:t>
             </a:r>
           </a:p>
           <a:p>
@@ -8582,11 +8687,11 @@
                 <a:solidFill>
                   <a:srgbClr val="94A3B8"/>
                 </a:solidFill>
-                <a:latin typeface="Segoe UI"/>
-              </a:defRPr>
-            </a:pPr>
-            <a:r>
-              <a:t>  FP16 Throughput: 989 TFLOPS</a:t>
+                <a:latin typeface="Malgun Gothic"/>
+              </a:defRPr>
+            </a:pPr>
+            <a:r>
+              <a:t>  FP16 처리량: 989 TFLOPS</a:t>
             </a:r>
           </a:p>
           <a:p>
@@ -8598,18 +8703,18 @@
                 <a:solidFill>
                   <a:srgbClr val="94A3B8"/>
                 </a:solidFill>
-                <a:latin typeface="Segoe UI"/>
-              </a:defRPr>
-            </a:pPr>
-            <a:r>
-              <a:t>  2x H200 Total: 282 GB VRAM</a:t>
-            </a:r>
-          </a:p>
-        </p:txBody>
-      </p:sp>
-      <p:sp>
-        <p:nvSpPr>
-          <p:cNvPr id="6" name="Rounded Rectangle 5"/>
+                <a:latin typeface="Malgun Gothic"/>
+              </a:defRPr>
+            </a:pPr>
+            <a:r>
+              <a:t>  2x H200 합계: 282 GB VRAM</a:t>
+            </a:r>
+          </a:p>
+        </p:txBody>
+      </p:sp>
+      <p:sp>
+        <p:nvSpPr>
+          <p:cNvPr id="7" name="Rounded Rectangle 6"/>
           <p:cNvSpPr/>
           <p:nvPr/>
         </p:nvSpPr>
@@ -8652,7 +8757,7 @@
       </p:sp>
       <p:sp>
         <p:nvSpPr>
-          <p:cNvPr id="7" name="TextBox 6"/>
+          <p:cNvPr id="8" name="TextBox 7"/>
           <p:cNvSpPr txBox="1"/>
           <p:nvPr/>
         </p:nvSpPr>
@@ -8677,18 +8782,18 @@
                 <a:solidFill>
                   <a:srgbClr val="38BDF8"/>
                 </a:solidFill>
-                <a:latin typeface="Segoe UI"/>
-              </a:defRPr>
-            </a:pPr>
-            <a:r>
-              <a:t>Model</a:t>
-            </a:r>
-          </a:p>
-        </p:txBody>
-      </p:sp>
-      <p:sp>
-        <p:nvSpPr>
-          <p:cNvPr id="8" name="TextBox 7"/>
+                <a:latin typeface="Malgun Gothic"/>
+              </a:defRPr>
+            </a:pPr>
+            <a:r>
+              <a:t>모델</a:t>
+            </a:r>
+          </a:p>
+        </p:txBody>
+      </p:sp>
+      <p:sp>
+        <p:nvSpPr>
+          <p:cNvPr id="9" name="TextBox 8"/>
           <p:cNvSpPr txBox="1"/>
           <p:nvPr/>
         </p:nvSpPr>
@@ -8713,7 +8818,7 @@
                 <a:solidFill>
                   <a:srgbClr val="38BDF8"/>
                 </a:solidFill>
-                <a:latin typeface="Segoe UI"/>
+                <a:latin typeface="Malgun Gothic"/>
               </a:defRPr>
             </a:pPr>
             <a:r>
@@ -8724,7 +8829,7 @@
       </p:sp>
       <p:sp>
         <p:nvSpPr>
-          <p:cNvPr id="9" name="TextBox 8"/>
+          <p:cNvPr id="10" name="TextBox 9"/>
           <p:cNvSpPr txBox="1"/>
           <p:nvPr/>
         </p:nvSpPr>
@@ -8749,7 +8854,7 @@
                 <a:solidFill>
                   <a:srgbClr val="38BDF8"/>
                 </a:solidFill>
-                <a:latin typeface="Segoe UI"/>
+                <a:latin typeface="Malgun Gothic"/>
               </a:defRPr>
             </a:pPr>
             <a:r>
@@ -8760,7 +8865,7 @@
       </p:sp>
       <p:sp>
         <p:nvSpPr>
-          <p:cNvPr id="10" name="TextBox 9"/>
+          <p:cNvPr id="11" name="TextBox 10"/>
           <p:cNvSpPr txBox="1"/>
           <p:nvPr/>
         </p:nvSpPr>
@@ -8785,18 +8890,18 @@
                 <a:solidFill>
                   <a:srgbClr val="38BDF8"/>
                 </a:solidFill>
-                <a:latin typeface="Segoe UI"/>
-              </a:defRPr>
-            </a:pPr>
-            <a:r>
-              <a:t>2x H200 Deployment</a:t>
-            </a:r>
-          </a:p>
-        </p:txBody>
-      </p:sp>
-      <p:sp>
-        <p:nvSpPr>
-          <p:cNvPr id="11" name="Rounded Rectangle 10"/>
+                <a:latin typeface="Malgun Gothic"/>
+              </a:defRPr>
+            </a:pPr>
+            <a:r>
+              <a:t>2x H200 배포 전략</a:t>
+            </a:r>
+          </a:p>
+        </p:txBody>
+      </p:sp>
+      <p:sp>
+        <p:nvSpPr>
+          <p:cNvPr id="12" name="Rounded Rectangle 11"/>
           <p:cNvSpPr/>
           <p:nvPr/>
         </p:nvSpPr>
@@ -8839,7 +8944,7 @@
       </p:sp>
       <p:sp>
         <p:nvSpPr>
-          <p:cNvPr id="12" name="TextBox 11"/>
+          <p:cNvPr id="13" name="TextBox 12"/>
           <p:cNvSpPr txBox="1"/>
           <p:nvPr/>
         </p:nvSpPr>
@@ -8864,7 +8969,7 @@
                 <a:solidFill>
                   <a:srgbClr val="E2E8F0"/>
                 </a:solidFill>
-                <a:latin typeface="Segoe UI"/>
+                <a:latin typeface="Malgun Gothic"/>
               </a:defRPr>
             </a:pPr>
             <a:r>
@@ -8875,7 +8980,7 @@
       </p:sp>
       <p:sp>
         <p:nvSpPr>
-          <p:cNvPr id="13" name="TextBox 12"/>
+          <p:cNvPr id="14" name="TextBox 13"/>
           <p:cNvSpPr txBox="1"/>
           <p:nvPr/>
         </p:nvSpPr>
@@ -8900,7 +9005,7 @@
                 <a:solidFill>
                   <a:srgbClr val="94A3B8"/>
                 </a:solidFill>
-                <a:latin typeface="Segoe UI"/>
+                <a:latin typeface="Malgun Gothic"/>
               </a:defRPr>
             </a:pPr>
             <a:r>
@@ -8911,7 +9016,7 @@
       </p:sp>
       <p:sp>
         <p:nvSpPr>
-          <p:cNvPr id="14" name="TextBox 13"/>
+          <p:cNvPr id="15" name="TextBox 14"/>
           <p:cNvSpPr txBox="1"/>
           <p:nvPr/>
         </p:nvSpPr>
@@ -8936,7 +9041,7 @@
                 <a:solidFill>
                   <a:srgbClr val="94A3B8"/>
                 </a:solidFill>
-                <a:latin typeface="Segoe UI"/>
+                <a:latin typeface="Malgun Gothic"/>
               </a:defRPr>
             </a:pPr>
             <a:r>
@@ -8947,7 +9052,7 @@
       </p:sp>
       <p:sp>
         <p:nvSpPr>
-          <p:cNvPr id="15" name="TextBox 14"/>
+          <p:cNvPr id="16" name="TextBox 15"/>
           <p:cNvSpPr txBox="1"/>
           <p:nvPr/>
         </p:nvSpPr>
@@ -8972,18 +9077,18 @@
                 <a:solidFill>
                   <a:srgbClr val="4ADE80"/>
                 </a:solidFill>
-                <a:latin typeface="Segoe UI"/>
-              </a:defRPr>
-            </a:pPr>
-            <a:r>
-              <a:t>Multi-model + large batch</a:t>
-            </a:r>
-          </a:p>
-        </p:txBody>
-      </p:sp>
-      <p:sp>
-        <p:nvSpPr>
-          <p:cNvPr id="16" name="Rounded Rectangle 15"/>
+                <a:latin typeface="Malgun Gothic"/>
+              </a:defRPr>
+            </a:pPr>
+            <a:r>
+              <a:t>멀티 모델 + 대량 배치</a:t>
+            </a:r>
+          </a:p>
+        </p:txBody>
+      </p:sp>
+      <p:sp>
+        <p:nvSpPr>
+          <p:cNvPr id="17" name="Rounded Rectangle 16"/>
           <p:cNvSpPr/>
           <p:nvPr/>
         </p:nvSpPr>
@@ -9026,7 +9131,7 @@
       </p:sp>
       <p:sp>
         <p:nvSpPr>
-          <p:cNvPr id="17" name="TextBox 16"/>
+          <p:cNvPr id="18" name="TextBox 17"/>
           <p:cNvSpPr txBox="1"/>
           <p:nvPr/>
         </p:nvSpPr>
@@ -9051,7 +9156,7 @@
                 <a:solidFill>
                   <a:srgbClr val="E2E8F0"/>
                 </a:solidFill>
-                <a:latin typeface="Segoe UI"/>
+                <a:latin typeface="Malgun Gothic"/>
               </a:defRPr>
             </a:pPr>
             <a:r>
@@ -9062,7 +9167,7 @@
       </p:sp>
       <p:sp>
         <p:nvSpPr>
-          <p:cNvPr id="18" name="TextBox 17"/>
+          <p:cNvPr id="19" name="TextBox 18"/>
           <p:cNvSpPr txBox="1"/>
           <p:nvPr/>
         </p:nvSpPr>
@@ -9087,7 +9192,7 @@
                 <a:solidFill>
                   <a:srgbClr val="94A3B8"/>
                 </a:solidFill>
-                <a:latin typeface="Segoe UI"/>
+                <a:latin typeface="Malgun Gothic"/>
               </a:defRPr>
             </a:pPr>
             <a:r>
@@ -9098,7 +9203,7 @@
       </p:sp>
       <p:sp>
         <p:nvSpPr>
-          <p:cNvPr id="19" name="TextBox 18"/>
+          <p:cNvPr id="20" name="TextBox 19"/>
           <p:cNvSpPr txBox="1"/>
           <p:nvPr/>
         </p:nvSpPr>
@@ -9123,7 +9228,7 @@
                 <a:solidFill>
                   <a:srgbClr val="94A3B8"/>
                 </a:solidFill>
-                <a:latin typeface="Segoe UI"/>
+                <a:latin typeface="Malgun Gothic"/>
               </a:defRPr>
             </a:pPr>
             <a:r>
@@ -9134,7 +9239,7 @@
       </p:sp>
       <p:sp>
         <p:nvSpPr>
-          <p:cNvPr id="20" name="TextBox 19"/>
+          <p:cNvPr id="21" name="TextBox 20"/>
           <p:cNvSpPr txBox="1"/>
           <p:nvPr/>
         </p:nvSpPr>
@@ -9159,18 +9264,18 @@
                 <a:solidFill>
                   <a:srgbClr val="4ADE80"/>
                 </a:solidFill>
-                <a:latin typeface="Segoe UI"/>
-              </a:defRPr>
-            </a:pPr>
-            <a:r>
-              <a:t>Multi-model + large batch</a:t>
-            </a:r>
-          </a:p>
-        </p:txBody>
-      </p:sp>
-      <p:sp>
-        <p:nvSpPr>
-          <p:cNvPr id="21" name="Rounded Rectangle 20"/>
+                <a:latin typeface="Malgun Gothic"/>
+              </a:defRPr>
+            </a:pPr>
+            <a:r>
+              <a:t>멀티 모델 + 대량 배치</a:t>
+            </a:r>
+          </a:p>
+        </p:txBody>
+      </p:sp>
+      <p:sp>
+        <p:nvSpPr>
+          <p:cNvPr id="22" name="Rounded Rectangle 21"/>
           <p:cNvSpPr/>
           <p:nvPr/>
         </p:nvSpPr>
@@ -9213,7 +9318,7 @@
       </p:sp>
       <p:sp>
         <p:nvSpPr>
-          <p:cNvPr id="22" name="TextBox 21"/>
+          <p:cNvPr id="23" name="TextBox 22"/>
           <p:cNvSpPr txBox="1"/>
           <p:nvPr/>
         </p:nvSpPr>
@@ -9238,7 +9343,7 @@
                 <a:solidFill>
                   <a:srgbClr val="E2E8F0"/>
                 </a:solidFill>
-                <a:latin typeface="Segoe UI"/>
+                <a:latin typeface="Malgun Gothic"/>
               </a:defRPr>
             </a:pPr>
             <a:r>
@@ -9249,7 +9354,7 @@
       </p:sp>
       <p:sp>
         <p:nvSpPr>
-          <p:cNvPr id="23" name="TextBox 22"/>
+          <p:cNvPr id="24" name="TextBox 23"/>
           <p:cNvSpPr txBox="1"/>
           <p:nvPr/>
         </p:nvSpPr>
@@ -9274,7 +9379,7 @@
                 <a:solidFill>
                   <a:srgbClr val="94A3B8"/>
                 </a:solidFill>
-                <a:latin typeface="Segoe UI"/>
+                <a:latin typeface="Malgun Gothic"/>
               </a:defRPr>
             </a:pPr>
             <a:r>
@@ -9285,7 +9390,7 @@
       </p:sp>
       <p:sp>
         <p:nvSpPr>
-          <p:cNvPr id="24" name="TextBox 23"/>
+          <p:cNvPr id="25" name="TextBox 24"/>
           <p:cNvSpPr txBox="1"/>
           <p:nvPr/>
         </p:nvSpPr>
@@ -9310,7 +9415,7 @@
                 <a:solidFill>
                   <a:srgbClr val="94A3B8"/>
                 </a:solidFill>
-                <a:latin typeface="Segoe UI"/>
+                <a:latin typeface="Malgun Gothic"/>
               </a:defRPr>
             </a:pPr>
             <a:r>
@@ -9321,7 +9426,7 @@
       </p:sp>
       <p:sp>
         <p:nvSpPr>
-          <p:cNvPr id="25" name="TextBox 24"/>
+          <p:cNvPr id="26" name="TextBox 25"/>
           <p:cNvSpPr txBox="1"/>
           <p:nvPr/>
         </p:nvSpPr>
@@ -9346,18 +9451,18 @@
                 <a:solidFill>
                   <a:srgbClr val="4ADE80"/>
                 </a:solidFill>
-                <a:latin typeface="Segoe UI"/>
-              </a:defRPr>
-            </a:pPr>
-            <a:r>
-              <a:t>Multi-model + large batch</a:t>
-            </a:r>
-          </a:p>
-        </p:txBody>
-      </p:sp>
-      <p:sp>
-        <p:nvSpPr>
-          <p:cNvPr id="26" name="Rounded Rectangle 25"/>
+                <a:latin typeface="Malgun Gothic"/>
+              </a:defRPr>
+            </a:pPr>
+            <a:r>
+              <a:t>멀티 모델 + 대량 배치</a:t>
+            </a:r>
+          </a:p>
+        </p:txBody>
+      </p:sp>
+      <p:sp>
+        <p:nvSpPr>
+          <p:cNvPr id="27" name="Rounded Rectangle 26"/>
           <p:cNvSpPr/>
           <p:nvPr/>
         </p:nvSpPr>
@@ -9400,7 +9505,7 @@
       </p:sp>
       <p:sp>
         <p:nvSpPr>
-          <p:cNvPr id="27" name="TextBox 26"/>
+          <p:cNvPr id="28" name="TextBox 27"/>
           <p:cNvSpPr txBox="1"/>
           <p:nvPr/>
         </p:nvSpPr>
@@ -9425,7 +9530,7 @@
                 <a:solidFill>
                   <a:srgbClr val="E2E8F0"/>
                 </a:solidFill>
-                <a:latin typeface="Segoe UI"/>
+                <a:latin typeface="Malgun Gothic"/>
               </a:defRPr>
             </a:pPr>
             <a:r>
@@ -9436,7 +9541,7 @@
       </p:sp>
       <p:sp>
         <p:nvSpPr>
-          <p:cNvPr id="28" name="TextBox 27"/>
+          <p:cNvPr id="29" name="TextBox 28"/>
           <p:cNvSpPr txBox="1"/>
           <p:nvPr/>
         </p:nvSpPr>
@@ -9461,7 +9566,7 @@
                 <a:solidFill>
                   <a:srgbClr val="94A3B8"/>
                 </a:solidFill>
-                <a:latin typeface="Segoe UI"/>
+                <a:latin typeface="Malgun Gothic"/>
               </a:defRPr>
             </a:pPr>
             <a:r>
@@ -9472,7 +9577,7 @@
       </p:sp>
       <p:sp>
         <p:nvSpPr>
-          <p:cNvPr id="29" name="TextBox 28"/>
+          <p:cNvPr id="30" name="TextBox 29"/>
           <p:cNvSpPr txBox="1"/>
           <p:nvPr/>
         </p:nvSpPr>
@@ -9497,7 +9602,7 @@
                 <a:solidFill>
                   <a:srgbClr val="94A3B8"/>
                 </a:solidFill>
-                <a:latin typeface="Segoe UI"/>
+                <a:latin typeface="Malgun Gothic"/>
               </a:defRPr>
             </a:pPr>
             <a:r>
@@ -9508,7 +9613,7 @@
       </p:sp>
       <p:sp>
         <p:nvSpPr>
-          <p:cNvPr id="30" name="TextBox 29"/>
+          <p:cNvPr id="31" name="TextBox 30"/>
           <p:cNvSpPr txBox="1"/>
           <p:nvPr/>
         </p:nvSpPr>
@@ -9533,18 +9638,18 @@
                 <a:solidFill>
                   <a:srgbClr val="4ADE80"/>
                 </a:solidFill>
-                <a:latin typeface="Segoe UI"/>
-              </a:defRPr>
-            </a:pPr>
-            <a:r>
-              <a:t>Requires 2x H200 (FP16)</a:t>
-            </a:r>
-          </a:p>
-        </p:txBody>
-      </p:sp>
-      <p:sp>
-        <p:nvSpPr>
-          <p:cNvPr id="31" name="Rounded Rectangle 30"/>
+                <a:latin typeface="Malgun Gothic"/>
+              </a:defRPr>
+            </a:pPr>
+            <a:r>
+              <a:t>2x H200 필수 (FP16)</a:t>
+            </a:r>
+          </a:p>
+        </p:txBody>
+      </p:sp>
+      <p:sp>
+        <p:nvSpPr>
+          <p:cNvPr id="32" name="Rounded Rectangle 31"/>
           <p:cNvSpPr/>
           <p:nvPr/>
         </p:nvSpPr>
@@ -9587,7 +9692,7 @@
       </p:sp>
       <p:sp>
         <p:nvSpPr>
-          <p:cNvPr id="32" name="TextBox 31"/>
+          <p:cNvPr id="33" name="TextBox 32"/>
           <p:cNvSpPr txBox="1"/>
           <p:nvPr/>
         </p:nvSpPr>
@@ -9612,7 +9717,7 @@
                 <a:solidFill>
                   <a:srgbClr val="E2E8F0"/>
                 </a:solidFill>
-                <a:latin typeface="Segoe UI"/>
+                <a:latin typeface="Malgun Gothic"/>
               </a:defRPr>
             </a:pPr>
             <a:r>
@@ -9623,7 +9728,7 @@
       </p:sp>
       <p:sp>
         <p:nvSpPr>
-          <p:cNvPr id="33" name="TextBox 32"/>
+          <p:cNvPr id="34" name="TextBox 33"/>
           <p:cNvSpPr txBox="1"/>
           <p:nvPr/>
         </p:nvSpPr>
@@ -9648,7 +9753,7 @@
                 <a:solidFill>
                   <a:srgbClr val="94A3B8"/>
                 </a:solidFill>
-                <a:latin typeface="Segoe UI"/>
+                <a:latin typeface="Malgun Gothic"/>
               </a:defRPr>
             </a:pPr>
             <a:r>
@@ -9659,7 +9764,7 @@
       </p:sp>
       <p:sp>
         <p:nvSpPr>
-          <p:cNvPr id="34" name="TextBox 33"/>
+          <p:cNvPr id="35" name="TextBox 34"/>
           <p:cNvSpPr txBox="1"/>
           <p:nvPr/>
         </p:nvSpPr>
@@ -9684,7 +9789,7 @@
                 <a:solidFill>
                   <a:srgbClr val="94A3B8"/>
                 </a:solidFill>
-                <a:latin typeface="Segoe UI"/>
+                <a:latin typeface="Malgun Gothic"/>
               </a:defRPr>
             </a:pPr>
             <a:r>
@@ -9695,7 +9800,7 @@
       </p:sp>
       <p:sp>
         <p:nvSpPr>
-          <p:cNvPr id="35" name="TextBox 34"/>
+          <p:cNvPr id="36" name="TextBox 35"/>
           <p:cNvSpPr txBox="1"/>
           <p:nvPr/>
         </p:nvSpPr>
@@ -9720,18 +9825,18 @@
                 <a:solidFill>
                   <a:srgbClr val="4ADE80"/>
                 </a:solidFill>
-                <a:latin typeface="Segoe UI"/>
-              </a:defRPr>
-            </a:pPr>
-            <a:r>
-              <a:t>Comfortable on 1x H200</a:t>
-            </a:r>
-          </a:p>
-        </p:txBody>
-      </p:sp>
-      <p:sp>
-        <p:nvSpPr>
-          <p:cNvPr id="36" name="Rounded Rectangle 35"/>
+                <a:latin typeface="Malgun Gothic"/>
+              </a:defRPr>
+            </a:pPr>
+            <a:r>
+              <a:t>1x H200으로 운영 가능</a:t>
+            </a:r>
+          </a:p>
+        </p:txBody>
+      </p:sp>
+      <p:sp>
+        <p:nvSpPr>
+          <p:cNvPr id="37" name="Rounded Rectangle 36"/>
           <p:cNvSpPr/>
           <p:nvPr/>
         </p:nvSpPr>
@@ -9774,7 +9879,7 @@
       </p:sp>
       <p:sp>
         <p:nvSpPr>
-          <p:cNvPr id="37" name="TextBox 36"/>
+          <p:cNvPr id="38" name="TextBox 37"/>
           <p:cNvSpPr txBox="1"/>
           <p:nvPr/>
         </p:nvSpPr>
@@ -9799,7 +9904,7 @@
                 <a:solidFill>
                   <a:srgbClr val="E2E8F0"/>
                 </a:solidFill>
-                <a:latin typeface="Segoe UI"/>
+                <a:latin typeface="Malgun Gothic"/>
               </a:defRPr>
             </a:pPr>
             <a:r>
@@ -9810,7 +9915,7 @@
       </p:sp>
       <p:sp>
         <p:nvSpPr>
-          <p:cNvPr id="38" name="TextBox 37"/>
+          <p:cNvPr id="39" name="TextBox 38"/>
           <p:cNvSpPr txBox="1"/>
           <p:nvPr/>
         </p:nvSpPr>
@@ -9835,7 +9940,7 @@
                 <a:solidFill>
                   <a:srgbClr val="94A3B8"/>
                 </a:solidFill>
-                <a:latin typeface="Segoe UI"/>
+                <a:latin typeface="Malgun Gothic"/>
               </a:defRPr>
             </a:pPr>
             <a:r>
@@ -9846,7 +9951,7 @@
       </p:sp>
       <p:sp>
         <p:nvSpPr>
-          <p:cNvPr id="39" name="TextBox 38"/>
+          <p:cNvPr id="40" name="TextBox 39"/>
           <p:cNvSpPr txBox="1"/>
           <p:nvPr/>
         </p:nvSpPr>
@@ -9871,7 +9976,7 @@
                 <a:solidFill>
                   <a:srgbClr val="94A3B8"/>
                 </a:solidFill>
-                <a:latin typeface="Segoe UI"/>
+                <a:latin typeface="Malgun Gothic"/>
               </a:defRPr>
             </a:pPr>
             <a:r>
@@ -9882,7 +9987,7 @@
       </p:sp>
       <p:sp>
         <p:nvSpPr>
-          <p:cNvPr id="40" name="TextBox 39"/>
+          <p:cNvPr id="41" name="TextBox 40"/>
           <p:cNvSpPr txBox="1"/>
           <p:nvPr/>
         </p:nvSpPr>
@@ -9907,25 +10012,25 @@
                 <a:solidFill>
                   <a:srgbClr val="4ADE80"/>
                 </a:solidFill>
-                <a:latin typeface="Segoe UI"/>
-              </a:defRPr>
-            </a:pPr>
-            <a:r>
-              <a:t>Comfortable on 1x H200</a:t>
-            </a:r>
-          </a:p>
-        </p:txBody>
-      </p:sp>
-      <p:sp>
-        <p:nvSpPr>
-          <p:cNvPr id="41" name="Rounded Rectangle 40"/>
+                <a:latin typeface="Malgun Gothic"/>
+              </a:defRPr>
+            </a:pPr>
+            <a:r>
+              <a:t>1x H200으로 운영 가능</a:t>
+            </a:r>
+          </a:p>
+        </p:txBody>
+      </p:sp>
+      <p:sp>
+        <p:nvSpPr>
+          <p:cNvPr id="42" name="Rounded Rectangle 41"/>
           <p:cNvSpPr/>
           <p:nvPr/>
         </p:nvSpPr>
         <p:spPr>
           <a:xfrm>
-            <a:off x="6217920" y="1188720"/>
-            <a:ext cx="5486400" cy="2286000"/>
+            <a:off x="6217920" y="1371600"/>
+            <a:ext cx="5486400" cy="2103120"/>
           </a:xfrm>
           <a:prstGeom prst="roundRect">
             <a:avLst/>
@@ -9963,13 +10068,13 @@
       </p:sp>
       <p:sp>
         <p:nvSpPr>
-          <p:cNvPr id="42" name="TextBox 41"/>
-          <p:cNvSpPr txBox="1"/>
-          <p:nvPr/>
-        </p:nvSpPr>
-        <p:spPr>
-          <a:xfrm>
-            <a:off x="6400800" y="1280160"/>
+          <p:cNvPr id="43" name="TextBox 42"/>
+          <p:cNvSpPr txBox="1"/>
+          <p:nvPr/>
+        </p:nvSpPr>
+        <p:spPr>
+          <a:xfrm>
+            <a:off x="6400800" y="1417320"/>
             <a:ext cx="5120640" cy="365760"/>
           </a:xfrm>
           <a:prstGeom prst="rect">
@@ -9988,25 +10093,25 @@
                 <a:solidFill>
                   <a:srgbClr val="4ADE80"/>
                 </a:solidFill>
-                <a:latin typeface="Segoe UI"/>
-              </a:defRPr>
-            </a:pPr>
-            <a:r>
-              <a:t>Why 2x H200 (Not 1x)</a:t>
-            </a:r>
-          </a:p>
-        </p:txBody>
-      </p:sp>
-      <p:sp>
-        <p:nvSpPr>
-          <p:cNvPr id="43" name="TextBox 42"/>
-          <p:cNvSpPr txBox="1"/>
-          <p:nvPr/>
-        </p:nvSpPr>
-        <p:spPr>
-          <a:xfrm>
-            <a:off x="6400800" y="1737360"/>
-            <a:ext cx="5120640" cy="1828800"/>
+                <a:latin typeface="Malgun Gothic"/>
+              </a:defRPr>
+            </a:pPr>
+            <a:r>
+              <a:t>왜 2대인가 (1대가 아닌 이유)</a:t>
+            </a:r>
+          </a:p>
+        </p:txBody>
+      </p:sp>
+      <p:sp>
+        <p:nvSpPr>
+          <p:cNvPr id="44" name="TextBox 43"/>
+          <p:cNvSpPr txBox="1"/>
+          <p:nvPr/>
+        </p:nvSpPr>
+        <p:spPr>
+          <a:xfrm>
+            <a:off x="6400800" y="1828800"/>
+            <a:ext cx="5120640" cy="1645920"/>
           </a:xfrm>
           <a:prstGeom prst="rect">
             <a:avLst/>
@@ -10027,11 +10132,11 @@
                 <a:solidFill>
                   <a:srgbClr val="94A3B8"/>
                 </a:solidFill>
-                <a:latin typeface="Segoe UI"/>
-              </a:defRPr>
-            </a:pPr>
-            <a:r>
-              <a:t>1. Multi-Model A/B Testing: Run UI-TARS + MAI-UI</a:t>
+                <a:latin typeface="Malgun Gothic"/>
+              </a:defRPr>
+            </a:pPr>
+            <a:r>
+              <a:t>1. 멀티 모델 A/B 테스트: UI-TARS + MAI-UI를 동시에</a:t>
             </a:r>
           </a:p>
           <a:p>
@@ -10043,11 +10148,11 @@
                 <a:solidFill>
                   <a:srgbClr val="94A3B8"/>
                 </a:solidFill>
-                <a:latin typeface="Segoe UI"/>
-              </a:defRPr>
-            </a:pPr>
-            <a:r>
-              <a:t>   simultaneously for comparison and automatic fallback</a:t>
+                <a:latin typeface="Malgun Gothic"/>
+              </a:defRPr>
+            </a:pPr>
+            <a:r>
+              <a:t>   운영하여 비교 및 자동 폴백 구현</a:t>
             </a:r>
           </a:p>
           <a:p>
@@ -10059,11 +10164,11 @@
                 <a:solidFill>
                   <a:srgbClr val="94A3B8"/>
                 </a:solidFill>
-                <a:latin typeface="Segoe UI"/>
-              </a:defRPr>
-            </a:pPr>
-            <a:r>
-              <a:t>2. 72B Model Access: Larger models need &gt;141GB total</a:t>
+                <a:latin typeface="Malgun Gothic"/>
+              </a:defRPr>
+            </a:pPr>
+            <a:r>
+              <a:t>2. 72B 모델 운영: 대형 모델은 141GB 이상 필요</a:t>
             </a:r>
           </a:p>
           <a:p>
@@ -10075,11 +10180,11 @@
                 <a:solidFill>
                   <a:srgbClr val="94A3B8"/>
                 </a:solidFill>
-                <a:latin typeface="Segoe UI"/>
-              </a:defRPr>
-            </a:pPr>
-            <a:r>
-              <a:t>   for comfortable FP16 serving with batch inference</a:t>
+                <a:latin typeface="Malgun Gothic"/>
+              </a:defRPr>
+            </a:pPr>
+            <a:r>
+              <a:t>   → 2대 텐서 병렬로 FP16 배치 추론 가능</a:t>
             </a:r>
           </a:p>
           <a:p>
@@ -10091,11 +10196,11 @@
                 <a:solidFill>
                   <a:srgbClr val="94A3B8"/>
                 </a:solidFill>
-                <a:latin typeface="Segoe UI"/>
-              </a:defRPr>
-            </a:pPr>
-            <a:r>
-              <a:t>3. Concurrent Sessions: Multiple RCS automation</a:t>
+                <a:latin typeface="Malgun Gothic"/>
+              </a:defRPr>
+            </a:pPr>
+            <a:r>
+              <a:t>3. 동시 세션: 다수 RCS 자동화 워크플로우의</a:t>
             </a:r>
           </a:p>
           <a:p>
@@ -10107,11 +10212,11 @@
                 <a:solidFill>
                   <a:srgbClr val="94A3B8"/>
                 </a:solidFill>
-                <a:latin typeface="Segoe UI"/>
-              </a:defRPr>
-            </a:pPr>
-            <a:r>
-              <a:t>   workflows need parallel GPU inference</a:t>
+                <a:latin typeface="Malgun Gothic"/>
+              </a:defRPr>
+            </a:pPr>
+            <a:r>
+              <a:t>   병렬 GPU 추론 처리 필요</a:t>
             </a:r>
           </a:p>
           <a:p>
@@ -10123,11 +10228,11 @@
                 <a:solidFill>
                   <a:srgbClr val="94A3B8"/>
                 </a:solidFill>
-                <a:latin typeface="Segoe UI"/>
-              </a:defRPr>
-            </a:pPr>
-            <a:r>
-              <a:t>4. Fine-Tuning: Training on proprietary CD-SEM/RCS</a:t>
+                <a:latin typeface="Malgun Gothic"/>
+              </a:defRPr>
+            </a:pPr>
+            <a:r>
+              <a:t>4. 파인튜닝: 자사 CD-SEM/RCS 스크린샷으로 학습 시</a:t>
             </a:r>
           </a:p>
           <a:p>
@@ -10139,11 +10244,11 @@
                 <a:solidFill>
                   <a:srgbClr val="94A3B8"/>
                 </a:solidFill>
-                <a:latin typeface="Segoe UI"/>
-              </a:defRPr>
-            </a:pPr>
-            <a:r>
-              <a:t>   screenshots requires 2-4x inference memory</a:t>
+                <a:latin typeface="Malgun Gothic"/>
+              </a:defRPr>
+            </a:pPr>
+            <a:r>
+              <a:t>   추론 대비 2~4배 메모리 필요</a:t>
             </a:r>
           </a:p>
           <a:p>
@@ -10155,11 +10260,11 @@
                 <a:solidFill>
                   <a:srgbClr val="94A3B8"/>
                 </a:solidFill>
-                <a:latin typeface="Segoe UI"/>
-              </a:defRPr>
-            </a:pPr>
-            <a:r>
-              <a:t>5. Future-Proofing: Next-gen models trend larger</a:t>
+                <a:latin typeface="Malgun Gothic"/>
+              </a:defRPr>
+            </a:pPr>
+            <a:r>
+              <a:t>5. 미래 대비: 차세대 모델은 더 큰 파라미터 추세</a:t>
             </a:r>
           </a:p>
         </p:txBody>
@@ -10213,15 +10318,15 @@
           <a:lstStyle/>
           <a:p>
             <a:pPr algn="l">
-              <a:defRPr sz="2800" b="1">
+              <a:defRPr sz="2600" b="1">
                 <a:solidFill>
                   <a:srgbClr val="38BDF8"/>
                 </a:solidFill>
-                <a:latin typeface="Segoe UI"/>
-              </a:defRPr>
-            </a:pPr>
-            <a:r>
-              <a:t>Cost-Benefit Analysis: API vs Self-Hosted</a:t>
+                <a:latin typeface="Malgun Gothic"/>
+              </a:defRPr>
+            </a:pPr>
+            <a:r>
+              <a:t>현행 대비 개선 효과: Kimi-VL (사내 운영) vs GUI 전용 모델 (별도 GPU)</a:t>
             </a:r>
           </a:p>
         </p:txBody>
@@ -10298,11 +10403,11 @@
                 <a:solidFill>
                   <a:srgbClr val="F87171"/>
                 </a:solidFill>
-                <a:latin typeface="Segoe UI"/>
-              </a:defRPr>
-            </a:pPr>
-            <a:r>
-              <a:t>Current: Cloud API (Kimi-VL)</a:t>
+                <a:latin typeface="Malgun Gothic"/>
+              </a:defRPr>
+            </a:pPr>
+            <a:r>
+              <a:t>현행: Kimi-VL (사내 서버 운영 중)</a:t>
             </a:r>
           </a:p>
         </p:txBody>
@@ -10337,11 +10442,11 @@
                 <a:solidFill>
                   <a:srgbClr val="94A3B8"/>
                 </a:solidFill>
-                <a:latin typeface="Segoe UI"/>
-              </a:defRPr>
-            </a:pPr>
-            <a:r>
-              <a:t>Ongoing Costs:</a:t>
+                <a:latin typeface="Malgun Gothic"/>
+              </a:defRPr>
+            </a:pPr>
+            <a:r>
+              <a:t>운영 환경:</a:t>
             </a:r>
           </a:p>
           <a:p>
@@ -10353,11 +10458,11 @@
                 <a:solidFill>
                   <a:srgbClr val="94A3B8"/>
                 </a:solidFill>
-                <a:latin typeface="Segoe UI"/>
-              </a:defRPr>
-            </a:pPr>
-            <a:r>
-              <a:t>  - Per-request API fees (vision tokens are expensive)</a:t>
+                <a:latin typeface="Malgun Gothic"/>
+              </a:defRPr>
+            </a:pPr>
+            <a:r>
+              <a:t>  - 사내 서버에서 Kimi-VL API 서빙 중</a:t>
             </a:r>
           </a:p>
           <a:p>
@@ -10369,11 +10474,11 @@
                 <a:solidFill>
                   <a:srgbClr val="94A3B8"/>
                 </a:solidFill>
-                <a:latin typeface="Segoe UI"/>
-              </a:defRPr>
-            </a:pPr>
-            <a:r>
-              <a:t>  - 500-2000ms latency per VLM call (network round-trip)</a:t>
+                <a:latin typeface="Malgun Gothic"/>
+              </a:defRPr>
+            </a:pPr>
+            <a:r>
+              <a:t>  - 범용 VLM으로 다양한 업무에 활용</a:t>
             </a:r>
           </a:p>
           <a:p>
@@ -10385,11 +10490,11 @@
                 <a:solidFill>
                   <a:srgbClr val="94A3B8"/>
                 </a:solidFill>
-                <a:latin typeface="Segoe UI"/>
-              </a:defRPr>
-            </a:pPr>
-            <a:r>
-              <a:t>  - Each RCS step = 3-5 VLM calls = 1.5-10s delay per step</a:t>
+                <a:latin typeface="Malgun Gothic"/>
+              </a:defRPr>
+            </a:pPr>
+            <a:r>
+              <a:t>  - GUI 자동화 외 다른 용도에도 사용 가능</a:t>
             </a:r>
           </a:p>
           <a:p>
@@ -10401,7 +10506,7 @@
                 <a:solidFill>
                   <a:srgbClr val="94A3B8"/>
                 </a:solidFill>
-                <a:latin typeface="Segoe UI"/>
+                <a:latin typeface="Malgun Gothic"/>
               </a:defRPr>
             </a:pPr>
           </a:p>
@@ -10414,11 +10519,11 @@
                 <a:solidFill>
                   <a:srgbClr val="94A3B8"/>
                 </a:solidFill>
-                <a:latin typeface="Segoe UI"/>
-              </a:defRPr>
-            </a:pPr>
-            <a:r>
-              <a:t>Risks:</a:t>
+                <a:latin typeface="Malgun Gothic"/>
+              </a:defRPr>
+            </a:pPr>
+            <a:r>
+              <a:t>GUI 자동화 한계:</a:t>
             </a:r>
           </a:p>
           <a:p>
@@ -10430,11 +10535,11 @@
                 <a:solidFill>
                   <a:srgbClr val="94A3B8"/>
                 </a:solidFill>
-                <a:latin typeface="Segoe UI"/>
-              </a:defRPr>
-            </a:pPr>
-            <a:r>
-              <a:t>  - Vendor dependency (API deprecation, pricing changes)</a:t>
+                <a:latin typeface="Malgun Gothic"/>
+              </a:defRPr>
+            </a:pPr>
+            <a:r>
+              <a:t>  - ScreenSpot-Pro 정확도 34.5% (전문 UI 기준)</a:t>
             </a:r>
           </a:p>
           <a:p>
@@ -10446,11 +10551,11 @@
                 <a:solidFill>
                   <a:srgbClr val="94A3B8"/>
                 </a:solidFill>
-                <a:latin typeface="Segoe UI"/>
-              </a:defRPr>
-            </a:pPr>
-            <a:r>
-              <a:t>  - Data privacy: screenshots sent to external servers</a:t>
+                <a:latin typeface="Malgun Gothic"/>
+              </a:defRPr>
+            </a:pPr>
+            <a:r>
+              <a:t>  - 밀집된 좁은 영역 UI 요소 인식 불가</a:t>
             </a:r>
           </a:p>
           <a:p>
@@ -10462,11 +10567,11 @@
                 <a:solidFill>
                   <a:srgbClr val="94A3B8"/>
                 </a:solidFill>
-                <a:latin typeface="Segoe UI"/>
-              </a:defRPr>
-            </a:pPr>
-            <a:r>
-              <a:t>  - Rate limiting during peak automation runs</a:t>
+                <a:latin typeface="Malgun Gothic"/>
+              </a:defRPr>
+            </a:pPr>
+            <a:r>
+              <a:t>  - 클릭 좌표가 인접 요소로 빈번하게 이탈</a:t>
             </a:r>
           </a:p>
           <a:p>
@@ -10478,11 +10583,11 @@
                 <a:solidFill>
                   <a:srgbClr val="94A3B8"/>
                 </a:solidFill>
-                <a:latin typeface="Segoe UI"/>
-              </a:defRPr>
-            </a:pPr>
-            <a:r>
-              <a:t>  - Cannot fine-tune on proprietary engineering UIs</a:t>
+                <a:latin typeface="Malgun Gothic"/>
+              </a:defRPr>
+            </a:pPr>
+            <a:r>
+              <a:t>  - 범용 모델의 근본적 한계 — 해결 불가</a:t>
             </a:r>
           </a:p>
           <a:p>
@@ -10494,7 +10599,7 @@
                 <a:solidFill>
                   <a:srgbClr val="94A3B8"/>
                 </a:solidFill>
-                <a:latin typeface="Segoe UI"/>
+                <a:latin typeface="Malgun Gothic"/>
               </a:defRPr>
             </a:pPr>
           </a:p>
@@ -10507,11 +10612,11 @@
                 <a:solidFill>
                   <a:srgbClr val="94A3B8"/>
                 </a:solidFill>
-                <a:latin typeface="Segoe UI"/>
-              </a:defRPr>
-            </a:pPr>
-            <a:r>
-              <a:t>Performance:</a:t>
+                <a:latin typeface="Malgun Gothic"/>
+              </a:defRPr>
+            </a:pPr>
+            <a:r>
+              <a:t>결론:</a:t>
             </a:r>
           </a:p>
           <a:p>
@@ -10523,11 +10628,11 @@
                 <a:solidFill>
                   <a:srgbClr val="94A3B8"/>
                 </a:solidFill>
-                <a:latin typeface="Segoe UI"/>
-              </a:defRPr>
-            </a:pPr>
-            <a:r>
-              <a:t>  - 34.5% accuracy on professional GUI grounding</a:t>
+                <a:latin typeface="Malgun Gothic"/>
+              </a:defRPr>
+            </a:pPr>
+            <a:r>
+              <a:t>  - Kimi-VL은 범용 업무에는 적합하나</a:t>
             </a:r>
           </a:p>
           <a:p>
@@ -10539,27 +10644,11 @@
                 <a:solidFill>
                   <a:srgbClr val="94A3B8"/>
                 </a:solidFill>
-                <a:latin typeface="Segoe UI"/>
-              </a:defRPr>
-            </a:pPr>
-            <a:r>
-              <a:t>  - Frequent misclicks requiring human intervention</a:t>
-            </a:r>
-          </a:p>
-          <a:p>
-            <a:pPr>
-              <a:spcAft>
-                <a:spcPts val="400"/>
-              </a:spcAft>
-              <a:defRPr sz="1200">
-                <a:solidFill>
-                  <a:srgbClr val="94A3B8"/>
-                </a:solidFill>
-                <a:latin typeface="Segoe UI"/>
-              </a:defRPr>
-            </a:pPr>
-            <a:r>
-              <a:t>  - Cannot reliably distinguish narrow-range elements</a:t>
+                <a:latin typeface="Malgun Gothic"/>
+              </a:defRPr>
+            </a:pPr>
+            <a:r>
+              <a:t>  - 정밀 GUI 자동화에는 전용 모델이 필요</a:t>
             </a:r>
           </a:p>
         </p:txBody>
@@ -10636,11 +10725,11 @@
                 <a:solidFill>
                   <a:srgbClr val="4ADE80"/>
                 </a:solidFill>
-                <a:latin typeface="Segoe UI"/>
-              </a:defRPr>
-            </a:pPr>
-            <a:r>
-              <a:t>Proposed: Self-Hosted (H200 x2)</a:t>
+                <a:latin typeface="Malgun Gothic"/>
+              </a:defRPr>
+            </a:pPr>
+            <a:r>
+              <a:t>제안: GUI 전용 모델 (별도 H200 x 2)</a:t>
             </a:r>
           </a:p>
         </p:txBody>
@@ -10675,11 +10764,11 @@
                 <a:solidFill>
                   <a:srgbClr val="94A3B8"/>
                 </a:solidFill>
-                <a:latin typeface="Segoe UI"/>
-              </a:defRPr>
-            </a:pPr>
-            <a:r>
-              <a:t>One-Time Investment:</a:t>
+                <a:latin typeface="Malgun Gothic"/>
+              </a:defRPr>
+            </a:pPr>
+            <a:r>
+              <a:t>운영 구조:</a:t>
             </a:r>
           </a:p>
           <a:p>
@@ -10691,11 +10780,11 @@
                 <a:solidFill>
                   <a:srgbClr val="94A3B8"/>
                 </a:solidFill>
-                <a:latin typeface="Segoe UI"/>
-              </a:defRPr>
-            </a:pPr>
-            <a:r>
-              <a:t>  - 2x H200 GPU hardware (282GB total VRAM)</a:t>
+                <a:latin typeface="Malgun Gothic"/>
+              </a:defRPr>
+            </a:pPr>
+            <a:r>
+              <a:t>  - 기존 Kimi-VL 서버는 그대로 유지</a:t>
             </a:r>
           </a:p>
           <a:p>
@@ -10707,11 +10796,11 @@
                 <a:solidFill>
                   <a:srgbClr val="94A3B8"/>
                 </a:solidFill>
-                <a:latin typeface="Segoe UI"/>
-              </a:defRPr>
-            </a:pPr>
-            <a:r>
-              <a:t>  - Zero per-request cost after setup</a:t>
+                <a:latin typeface="Malgun Gothic"/>
+              </a:defRPr>
+            </a:pPr>
+            <a:r>
+              <a:t>  - 별도 H200 GPU 2대에 GUI 전용 모델 배포</a:t>
             </a:r>
           </a:p>
           <a:p>
@@ -10723,11 +10812,11 @@
                 <a:solidFill>
                   <a:srgbClr val="94A3B8"/>
                 </a:solidFill>
-                <a:latin typeface="Segoe UI"/>
-              </a:defRPr>
-            </a:pPr>
-            <a:r>
-              <a:t>  - vLLM serving: production-ready inference server</a:t>
+                <a:latin typeface="Malgun Gothic"/>
+              </a:defRPr>
+            </a:pPr>
+            <a:r>
+              <a:t>  - vLLM 기반 OpenAI 호환 API 서빙</a:t>
             </a:r>
           </a:p>
           <a:p>
@@ -10739,7 +10828,7 @@
                 <a:solidFill>
                   <a:srgbClr val="94A3B8"/>
                 </a:solidFill>
-                <a:latin typeface="Segoe UI"/>
+                <a:latin typeface="Malgun Gothic"/>
               </a:defRPr>
             </a:pPr>
           </a:p>
@@ -10752,11 +10841,11 @@
                 <a:solidFill>
                   <a:srgbClr val="94A3B8"/>
                 </a:solidFill>
-                <a:latin typeface="Segoe UI"/>
-              </a:defRPr>
-            </a:pPr>
-            <a:r>
-              <a:t>Advantages:</a:t>
+                <a:latin typeface="Malgun Gothic"/>
+              </a:defRPr>
+            </a:pPr>
+            <a:r>
+              <a:t>기대 효과:</a:t>
             </a:r>
           </a:p>
           <a:p>
@@ -10768,11 +10857,11 @@
                 <a:solidFill>
                   <a:srgbClr val="94A3B8"/>
                 </a:solidFill>
-                <a:latin typeface="Segoe UI"/>
-              </a:defRPr>
-            </a:pPr>
-            <a:r>
-              <a:t>  - Full data privacy: all inference on-premise</a:t>
+                <a:latin typeface="Malgun Gothic"/>
+              </a:defRPr>
+            </a:pPr>
+            <a:r>
+              <a:t>  - 정확도 61.6~67.9% (UI-TARS, MAI-UI)</a:t>
             </a:r>
           </a:p>
           <a:p>
@@ -10784,11 +10873,11 @@
                 <a:solidFill>
                   <a:srgbClr val="94A3B8"/>
                 </a:solidFill>
-                <a:latin typeface="Segoe UI"/>
-              </a:defRPr>
-            </a:pPr>
-            <a:r>
-              <a:t>  - &lt;100ms latency (local GPU vs cloud round-trip)</a:t>
+                <a:latin typeface="Malgun Gothic"/>
+              </a:defRPr>
+            </a:pPr>
+            <a:r>
+              <a:t>  - 현재 대비 +78% 정확도 향상</a:t>
             </a:r>
           </a:p>
           <a:p>
@@ -10800,11 +10889,11 @@
                 <a:solidFill>
                   <a:srgbClr val="94A3B8"/>
                 </a:solidFill>
-                <a:latin typeface="Segoe UI"/>
-              </a:defRPr>
-            </a:pPr>
-            <a:r>
-              <a:t>  - No rate limits: unlimited concurrent requests</a:t>
+                <a:latin typeface="Malgun Gothic"/>
+              </a:defRPr>
+            </a:pPr>
+            <a:r>
+              <a:t>  - 좁은 영역 밀집 UI 요소도 정밀 인식</a:t>
             </a:r>
           </a:p>
           <a:p>
@@ -10816,11 +10905,11 @@
                 <a:solidFill>
                   <a:srgbClr val="94A3B8"/>
                 </a:solidFill>
-                <a:latin typeface="Segoe UI"/>
-              </a:defRPr>
-            </a:pPr>
-            <a:r>
-              <a:t>  - Fine-tune on proprietary RCS/CD-SEM screenshots</a:t>
+                <a:latin typeface="Malgun Gothic"/>
+              </a:defRPr>
+            </a:pPr>
+            <a:r>
+              <a:t>  - RCS/CD-SEM 스크린샷으로 파인튜닝 가능</a:t>
             </a:r>
           </a:p>
           <a:p>
@@ -10832,7 +10921,7 @@
                 <a:solidFill>
                   <a:srgbClr val="94A3B8"/>
                 </a:solidFill>
-                <a:latin typeface="Segoe UI"/>
+                <a:latin typeface="Malgun Gothic"/>
               </a:defRPr>
             </a:pPr>
           </a:p>
@@ -10845,11 +10934,11 @@
                 <a:solidFill>
                   <a:srgbClr val="94A3B8"/>
                 </a:solidFill>
-                <a:latin typeface="Segoe UI"/>
-              </a:defRPr>
-            </a:pPr>
-            <a:r>
-              <a:t>Performance:</a:t>
+                <a:latin typeface="Malgun Gothic"/>
+              </a:defRPr>
+            </a:pPr>
+            <a:r>
+              <a:t>추가 이점:</a:t>
             </a:r>
           </a:p>
           <a:p>
@@ -10861,11 +10950,11 @@
                 <a:solidFill>
                   <a:srgbClr val="94A3B8"/>
                 </a:solidFill>
-                <a:latin typeface="Segoe UI"/>
-              </a:defRPr>
-            </a:pPr>
-            <a:r>
-              <a:t>  - 61.6-67.9% accuracy (GUI-specialized models)</a:t>
+                <a:latin typeface="Malgun Gothic"/>
+              </a:defRPr>
+            </a:pPr>
+            <a:r>
+              <a:t>  - Kimi-VL과 독립 운영 → 기존 서비스 영향 없음</a:t>
             </a:r>
           </a:p>
           <a:p>
@@ -10877,11 +10966,11 @@
                 <a:solidFill>
                   <a:srgbClr val="94A3B8"/>
                 </a:solidFill>
-                <a:latin typeface="Segoe UI"/>
-              </a:defRPr>
-            </a:pPr>
-            <a:r>
-              <a:t>  - +78% improvement over current Kimi-VL</a:t>
+                <a:latin typeface="Malgun Gothic"/>
+              </a:defRPr>
+            </a:pPr>
+            <a:r>
+              <a:t>  - 데이터 보안: 모든 추론이 사내에서 완결</a:t>
             </a:r>
           </a:p>
           <a:p>
@@ -10893,27 +10982,11 @@
                 <a:solidFill>
                   <a:srgbClr val="94A3B8"/>
                 </a:solidFill>
-                <a:latin typeface="Segoe UI"/>
-              </a:defRPr>
-            </a:pPr>
-            <a:r>
-              <a:t>  - Reliable narrow-range element detection</a:t>
-            </a:r>
-          </a:p>
-          <a:p>
-            <a:pPr>
-              <a:spcAft>
-                <a:spcPts val="400"/>
-              </a:spcAft>
-              <a:defRPr sz="1200">
-                <a:solidFill>
-                  <a:srgbClr val="94A3B8"/>
-                </a:solidFill>
-                <a:latin typeface="Segoe UI"/>
-              </a:defRPr>
-            </a:pPr>
-            <a:r>
-              <a:t>  - Run multiple models for fallback/ensemble</a:t>
+                <a:latin typeface="Malgun Gothic"/>
+              </a:defRPr>
+            </a:pPr>
+            <a:r>
+              <a:t>  - 멀티 모델 앙상블/폴백으로 안정성 확보</a:t>
             </a:r>
           </a:p>
         </p:txBody>
@@ -10971,11 +11044,11 @@
                 <a:solidFill>
                   <a:srgbClr val="38BDF8"/>
                 </a:solidFill>
-                <a:latin typeface="Segoe UI"/>
-              </a:defRPr>
-            </a:pPr>
-            <a:r>
-              <a:t>Implementation Roadmap</a:t>
+                <a:latin typeface="Malgun Gothic"/>
+              </a:defRPr>
+            </a:pPr>
+            <a:r>
+              <a:t>구현 로드맵</a:t>
             </a:r>
           </a:p>
         </p:txBody>
@@ -11052,11 +11125,11 @@
                 <a:solidFill>
                   <a:srgbClr val="38BDF8"/>
                 </a:solidFill>
-                <a:latin typeface="Segoe UI"/>
-              </a:defRPr>
-            </a:pPr>
-            <a:r>
-              <a:t>Phase 1: Immediate (Week 1-2)</a:t>
+                <a:latin typeface="Malgun Gothic"/>
+              </a:defRPr>
+            </a:pPr>
+            <a:r>
+              <a:t>1단계: 즉시 착수 (1~2주차)</a:t>
             </a:r>
           </a:p>
         </p:txBody>
@@ -11088,11 +11161,11 @@
                 <a:solidFill>
                   <a:srgbClr val="94A3B8"/>
                 </a:solidFill>
-                <a:latin typeface="Segoe UI"/>
-              </a:defRPr>
-            </a:pPr>
-            <a:r>
-              <a:t>  Deploy UI-TARS-1.5-7B on H200 via vLLM</a:t>
+                <a:latin typeface="Malgun Gothic"/>
+              </a:defRPr>
+            </a:pPr>
+            <a:r>
+              <a:t>  H200에 UI-TARS-1.5-7B 배포 (vLLM 서빙)</a:t>
             </a:r>
           </a:p>
         </p:txBody>
@@ -11124,11 +11197,11 @@
                 <a:solidFill>
                   <a:srgbClr val="94A3B8"/>
                 </a:solidFill>
-                <a:latin typeface="Segoe UI"/>
-              </a:defRPr>
-            </a:pPr>
-            <a:r>
-              <a:t>  OpenAI-compatible API — minimal code changes to existing poc/work/ pipeline</a:t>
+                <a:latin typeface="Malgun Gothic"/>
+              </a:defRPr>
+            </a:pPr>
+            <a:r>
+              <a:t>  OpenAI 호환 API — 기존 poc/work/ 파이프라인 코드 변경 최소화</a:t>
             </a:r>
           </a:p>
         </p:txBody>
@@ -11160,11 +11233,11 @@
                 <a:solidFill>
                   <a:srgbClr val="94A3B8"/>
                 </a:solidFill>
-                <a:latin typeface="Segoe UI"/>
-              </a:defRPr>
-            </a:pPr>
-            <a:r>
-              <a:t>  A/B test: Kimi-VL vs UI-TARS side-by-side on RCS login + tab switching</a:t>
+                <a:latin typeface="Malgun Gothic"/>
+              </a:defRPr>
+            </a:pPr>
+            <a:r>
+              <a:t>  A/B 테스트: Kimi-VL vs UI-TARS 병행 비교 (RCS 로그인 + 탭 전환)</a:t>
             </a:r>
           </a:p>
         </p:txBody>
@@ -11241,11 +11314,11 @@
                 <a:solidFill>
                   <a:srgbClr val="FBBF24"/>
                 </a:solidFill>
-                <a:latin typeface="Segoe UI"/>
-              </a:defRPr>
-            </a:pPr>
-            <a:r>
-              <a:t>Phase 2: Validation (Week 3-4)</a:t>
+                <a:latin typeface="Malgun Gothic"/>
+              </a:defRPr>
+            </a:pPr>
+            <a:r>
+              <a:t>2단계: 검증 (3~4주차)</a:t>
             </a:r>
           </a:p>
         </p:txBody>
@@ -11277,11 +11350,11 @@
                 <a:solidFill>
                   <a:srgbClr val="94A3B8"/>
                 </a:solidFill>
-                <a:latin typeface="Segoe UI"/>
-              </a:defRPr>
-            </a:pPr>
-            <a:r>
-              <a:t>  Deploy MAI-UI-8B as secondary model (2nd GPU)</a:t>
+                <a:latin typeface="Malgun Gothic"/>
+              </a:defRPr>
+            </a:pPr>
+            <a:r>
+              <a:t>  2번째 GPU에 MAI-UI-8B 배포 (보조 모델)</a:t>
             </a:r>
           </a:p>
         </p:txBody>
@@ -11313,11 +11386,11 @@
                 <a:solidFill>
                   <a:srgbClr val="94A3B8"/>
                 </a:solidFill>
-                <a:latin typeface="Segoe UI"/>
-              </a:defRPr>
-            </a:pPr>
-            <a:r>
-              <a:t>  Benchmark on real RCS screenshots: login, tool list, recipe editor</a:t>
+                <a:latin typeface="Malgun Gothic"/>
+              </a:defRPr>
+            </a:pPr>
+            <a:r>
+              <a:t>  실제 RCS 스크린샷으로 벤치마크: 로그인, 도구 목록, 레시피 편집기</a:t>
             </a:r>
           </a:p>
         </p:txBody>
@@ -11349,11 +11422,11 @@
                 <a:solidFill>
                   <a:srgbClr val="94A3B8"/>
                 </a:solidFill>
-                <a:latin typeface="Segoe UI"/>
-              </a:defRPr>
-            </a:pPr>
-            <a:r>
-              <a:t>  Measure click accuracy, especially on dense/narrow-range controls</a:t>
+                <a:latin typeface="Malgun Gothic"/>
+              </a:defRPr>
+            </a:pPr>
+            <a:r>
+              <a:t>  밀집/좁은 영역 컨트롤에서의 클릭 정확도 측정</a:t>
             </a:r>
           </a:p>
         </p:txBody>
@@ -11385,11 +11458,11 @@
                 <a:solidFill>
                   <a:srgbClr val="94A3B8"/>
                 </a:solidFill>
-                <a:latin typeface="Segoe UI"/>
-              </a:defRPr>
-            </a:pPr>
-            <a:r>
-              <a:t>  Implement model ensemble/fallback: try UI-TARS first, fall back to MAI-UI</a:t>
+                <a:latin typeface="Malgun Gothic"/>
+              </a:defRPr>
+            </a:pPr>
+            <a:r>
+              <a:t>  모델 앙상블/폴백 구현: UI-TARS 우선 → MAI-UI 보조</a:t>
             </a:r>
           </a:p>
         </p:txBody>
@@ -11466,11 +11539,11 @@
                 <a:solidFill>
                   <a:srgbClr val="4ADE80"/>
                 </a:solidFill>
-                <a:latin typeface="Segoe UI"/>
-              </a:defRPr>
-            </a:pPr>
-            <a:r>
-              <a:t>Phase 3: Optimization (Month 2-3)</a:t>
+                <a:latin typeface="Malgun Gothic"/>
+              </a:defRPr>
+            </a:pPr>
+            <a:r>
+              <a:t>3단계: 최적화 (2~3개월차)</a:t>
             </a:r>
           </a:p>
         </p:txBody>
@@ -11502,11 +11575,11 @@
                 <a:solidFill>
                   <a:srgbClr val="94A3B8"/>
                 </a:solidFill>
-                <a:latin typeface="Segoe UI"/>
-              </a:defRPr>
-            </a:pPr>
-            <a:r>
-              <a:t>  Collect proprietary RCS/CD-SEM screenshot dataset (~1000+ labeled images)</a:t>
+                <a:latin typeface="Malgun Gothic"/>
+              </a:defRPr>
+            </a:pPr>
+            <a:r>
+              <a:t>  자사 RCS/CD-SEM 스크린샷 데이터셋 구축 (~1,000장 이상 라벨링)</a:t>
             </a:r>
           </a:p>
         </p:txBody>
@@ -11538,11 +11611,11 @@
                 <a:solidFill>
                   <a:srgbClr val="94A3B8"/>
                 </a:solidFill>
-                <a:latin typeface="Segoe UI"/>
-              </a:defRPr>
-            </a:pPr>
-            <a:r>
-              <a:t>  Fine-tune UI-TARS-1.5-7B on domain-specific data (LoRA, ~16GB VRAM)</a:t>
+                <a:latin typeface="Malgun Gothic"/>
+              </a:defRPr>
+            </a:pPr>
+            <a:r>
+              <a:t>  UI-TARS-1.5-7B 도메인 파인튜닝 (LoRA, ~16GB VRAM)</a:t>
             </a:r>
           </a:p>
         </p:txBody>
@@ -11574,11 +11647,11 @@
                 <a:solidFill>
                   <a:srgbClr val="94A3B8"/>
                 </a:solidFill>
-                <a:latin typeface="Segoe UI"/>
-              </a:defRPr>
-            </a:pPr>
-            <a:r>
-              <a:t>  Evaluate 72B models (UI-TARS-72B) using 2x H200 tensor parallel</a:t>
+                <a:latin typeface="Malgun Gothic"/>
+              </a:defRPr>
+            </a:pPr>
+            <a:r>
+              <a:t>  72B 모델 평가 (UI-TARS-72B) — 2x H200 텐서 병렬 활용</a:t>
             </a:r>
           </a:p>
         </p:txBody>
@@ -11610,11 +11683,11 @@
                 <a:solidFill>
                   <a:srgbClr val="94A3B8"/>
                 </a:solidFill>
-                <a:latin typeface="Segoe UI"/>
-              </a:defRPr>
-            </a:pPr>
-            <a:r>
-              <a:t>  Integrate into full RCS recipe creation pipeline</a:t>
+                <a:latin typeface="Malgun Gothic"/>
+              </a:defRPr>
+            </a:pPr>
+            <a:r>
+              <a:t>  전체 RCS 레시피 생성 파이프라인에 통합</a:t>
             </a:r>
           </a:p>
         </p:txBody>
@@ -11691,11 +11764,11 @@
                 <a:solidFill>
                   <a:srgbClr val="818CF8"/>
                 </a:solidFill>
-                <a:latin typeface="Segoe UI"/>
-              </a:defRPr>
-            </a:pPr>
-            <a:r>
-              <a:t>Phase 4: Production (Month 3+)</a:t>
+                <a:latin typeface="Malgun Gothic"/>
+              </a:defRPr>
+            </a:pPr>
+            <a:r>
+              <a:t>4단계: 프로덕션 (3개월차~)</a:t>
             </a:r>
           </a:p>
         </p:txBody>
@@ -11727,11 +11800,11 @@
                 <a:solidFill>
                   <a:srgbClr val="94A3B8"/>
                 </a:solidFill>
-                <a:latin typeface="Segoe UI"/>
-              </a:defRPr>
-            </a:pPr>
-            <a:r>
-              <a:t>  Production deployment with monitoring and auto-recovery</a:t>
+                <a:latin typeface="Malgun Gothic"/>
+              </a:defRPr>
+            </a:pPr>
+            <a:r>
+              <a:t>  모니터링 및 자동 복구 기능 포함 프로덕션 배포</a:t>
             </a:r>
           </a:p>
         </p:txBody>
@@ -11763,11 +11836,11 @@
                 <a:solidFill>
                   <a:srgbClr val="94A3B8"/>
                 </a:solidFill>
-                <a:latin typeface="Segoe UI"/>
-              </a:defRPr>
-            </a:pPr>
-            <a:r>
-              <a:t>  Expand to additional engineering tools (VeritySEM, CD-SEM viewer)</a:t>
+                <a:latin typeface="Malgun Gothic"/>
+              </a:defRPr>
+            </a:pPr>
+            <a:r>
+              <a:t>  추가 엔지니어링 도구로 확장 (VeritySEM, CD-SEM 뷰어)</a:t>
             </a:r>
           </a:p>
         </p:txBody>
@@ -11799,11 +11872,11 @@
                 <a:solidFill>
                   <a:srgbClr val="94A3B8"/>
                 </a:solidFill>
-                <a:latin typeface="Segoe UI"/>
-              </a:defRPr>
-            </a:pPr>
-            <a:r>
-              <a:t>  Evaluate next-gen models (UI-TARS-2, MAI-UI v2) as they release</a:t>
+                <a:latin typeface="Malgun Gothic"/>
+              </a:defRPr>
+            </a:pPr>
+            <a:r>
+              <a:t>  차세대 모델 (UI-TARS-2, MAI-UI v2) 출시 시 평가 및 교체</a:t>
             </a:r>
           </a:p>
         </p:txBody>
@@ -11835,11 +11908,11 @@
                 <a:solidFill>
                   <a:srgbClr val="94A3B8"/>
                 </a:solidFill>
-                <a:latin typeface="Segoe UI"/>
-              </a:defRPr>
-            </a:pPr>
-            <a:r>
-              <a:t>  Build internal benchmark dataset for continuous model evaluation</a:t>
+                <a:latin typeface="Malgun Gothic"/>
+              </a:defRPr>
+            </a:pPr>
+            <a:r>
+              <a:t>  내부 벤치마크 데이터셋 구축으로 지속적 모델 평가 체계 확립</a:t>
             </a:r>
           </a:p>
         </p:txBody>
@@ -11897,11 +11970,11 @@
                 <a:solidFill>
                   <a:srgbClr val="38BDF8"/>
                 </a:solidFill>
-                <a:latin typeface="Segoe UI"/>
-              </a:defRPr>
-            </a:pPr>
-            <a:r>
-              <a:t>Summary &amp; Request</a:t>
+                <a:latin typeface="Malgun Gothic"/>
+              </a:defRPr>
+            </a:pPr>
+            <a:r>
+              <a:t>요약 및 요청사항</a:t>
             </a:r>
           </a:p>
         </p:txBody>
@@ -11936,11 +12009,11 @@
                 <a:solidFill>
                   <a:srgbClr val="94A3B8"/>
                 </a:solidFill>
-                <a:latin typeface="Segoe UI"/>
-              </a:defRPr>
-            </a:pPr>
-            <a:r>
-              <a:t>1.  Current Kimi-VL model scores 34.5% on professional GUI grounding</a:t>
+                <a:latin typeface="Malgun Gothic"/>
+              </a:defRPr>
+            </a:pPr>
+            <a:r>
+              <a:t>1.  현재 사내 운영 중인 Kimi-VL은 ScreenSpot-Pro 기준 34.5% 정확도</a:t>
             </a:r>
           </a:p>
           <a:p>
@@ -11952,11 +12025,11 @@
                 <a:solidFill>
                   <a:srgbClr val="94A3B8"/>
                 </a:solidFill>
-                <a:latin typeface="Segoe UI"/>
-              </a:defRPr>
-            </a:pPr>
-            <a:r>
-              <a:t>     — insufficient for reliable CD-SEM/RCS recipe automation</a:t>
+                <a:latin typeface="Malgun Gothic"/>
+              </a:defRPr>
+            </a:pPr>
+            <a:r>
+              <a:t>     — CD-SEM/RCS 레시피 자동화에 신뢰할 수 없는 수준</a:t>
             </a:r>
           </a:p>
           <a:p>
@@ -11968,7 +12041,7 @@
                 <a:solidFill>
                   <a:srgbClr val="94A3B8"/>
                 </a:solidFill>
-                <a:latin typeface="Segoe UI"/>
+                <a:latin typeface="Malgun Gothic"/>
               </a:defRPr>
             </a:pPr>
           </a:p>
@@ -11981,11 +12054,11 @@
                 <a:solidFill>
                   <a:srgbClr val="94A3B8"/>
                 </a:solidFill>
-                <a:latin typeface="Segoe UI"/>
-              </a:defRPr>
-            </a:pPr>
-            <a:r>
-              <a:t>2.  Kimi-VL fails on narrow-range UI elements (&lt;20px spacing)</a:t>
+                <a:latin typeface="Malgun Gothic"/>
+              </a:defRPr>
+            </a:pPr>
+            <a:r>
+              <a:t>2.  특히 좁은 영역에 밀집된 UI 요소 (&lt;20px 간격)를 구분하지 못함</a:t>
             </a:r>
           </a:p>
           <a:p>
@@ -11997,11 +12070,11 @@
                 <a:solidFill>
                   <a:srgbClr val="94A3B8"/>
                 </a:solidFill>
-                <a:latin typeface="Segoe UI"/>
-              </a:defRPr>
-            </a:pPr>
-            <a:r>
-              <a:t>     — critical limitation for dense engineering control panels</a:t>
+                <a:latin typeface="Malgun Gothic"/>
+              </a:defRPr>
+            </a:pPr>
+            <a:r>
+              <a:t>     — RCS 레시피 편집기의 밀집 컨트롤 패널에서 치명적</a:t>
             </a:r>
           </a:p>
           <a:p>
@@ -12013,7 +12086,7 @@
                 <a:solidFill>
                   <a:srgbClr val="94A3B8"/>
                 </a:solidFill>
-                <a:latin typeface="Segoe UI"/>
+                <a:latin typeface="Malgun Gothic"/>
               </a:defRPr>
             </a:pPr>
           </a:p>
@@ -12026,11 +12099,11 @@
                 <a:solidFill>
                   <a:srgbClr val="94A3B8"/>
                 </a:solidFill>
-                <a:latin typeface="Segoe UI"/>
-              </a:defRPr>
-            </a:pPr>
-            <a:r>
-              <a:t>3.  GUI-specialized open-source models (UI-TARS, MAI-UI) achieve</a:t>
+                <a:latin typeface="Malgun Gothic"/>
+              </a:defRPr>
+            </a:pPr>
+            <a:r>
+              <a:t>3.  GUI 전용 오픈소스 모델 (UI-TARS, MAI-UI)은 61~68% 정확도</a:t>
             </a:r>
           </a:p>
           <a:p>
@@ -12042,11 +12115,11 @@
                 <a:solidFill>
                   <a:srgbClr val="94A3B8"/>
                 </a:solidFill>
-                <a:latin typeface="Segoe UI"/>
-              </a:defRPr>
-            </a:pPr>
-            <a:r>
-              <a:t>     61-68% accuracy — a +78% improvement with self-hosted inference</a:t>
+                <a:latin typeface="Malgun Gothic"/>
+              </a:defRPr>
+            </a:pPr>
+            <a:r>
+              <a:t>     — 현재 대비 +78% 향상, 7B 소형 모델로도 달성 가능</a:t>
             </a:r>
           </a:p>
           <a:p>
@@ -12058,7 +12131,7 @@
                 <a:solidFill>
                   <a:srgbClr val="94A3B8"/>
                 </a:solidFill>
-                <a:latin typeface="Segoe UI"/>
+                <a:latin typeface="Malgun Gothic"/>
               </a:defRPr>
             </a:pPr>
           </a:p>
@@ -12071,11 +12144,11 @@
                 <a:solidFill>
                   <a:srgbClr val="94A3B8"/>
                 </a:solidFill>
-                <a:latin typeface="Segoe UI"/>
-              </a:defRPr>
-            </a:pPr>
-            <a:r>
-              <a:t>4.  Self-hosting eliminates API costs, provides data privacy,</a:t>
+                <a:latin typeface="Malgun Gothic"/>
+              </a:defRPr>
+            </a:pPr>
+            <a:r>
+              <a:t>4.  기존 Kimi-VL 서버와 별도로 운영하여</a:t>
             </a:r>
           </a:p>
           <a:p>
@@ -12087,11 +12160,11 @@
                 <a:solidFill>
                   <a:srgbClr val="94A3B8"/>
                 </a:solidFill>
-                <a:latin typeface="Segoe UI"/>
-              </a:defRPr>
-            </a:pPr>
-            <a:r>
-              <a:t>     enables fine-tuning on proprietary screenshots, and reduces</a:t>
+                <a:latin typeface="Malgun Gothic"/>
+              </a:defRPr>
+            </a:pPr>
+            <a:r>
+              <a:t>     기존 서비스에 영향 없이 GUI 자동화 전용 인프라 구축</a:t>
             </a:r>
           </a:p>
           <a:p>
@@ -12103,12 +12176,9 @@
                 <a:solidFill>
                   <a:srgbClr val="94A3B8"/>
                 </a:solidFill>
-                <a:latin typeface="Segoe UI"/>
-              </a:defRPr>
-            </a:pPr>
-            <a:r>
-              <a:t>     inference latency from seconds to milliseconds</a:t>
-            </a:r>
+                <a:latin typeface="Malgun Gothic"/>
+              </a:defRPr>
+            </a:pPr>
           </a:p>
           <a:p>
             <a:pPr>
@@ -12119,9 +12189,12 @@
                 <a:solidFill>
                   <a:srgbClr val="94A3B8"/>
                 </a:solidFill>
-                <a:latin typeface="Segoe UI"/>
-              </a:defRPr>
-            </a:pPr>
+                <a:latin typeface="Malgun Gothic"/>
+              </a:defRPr>
+            </a:pPr>
+            <a:r>
+              <a:t>5.  H200 GPU 2대 (282GB VRAM)로 멀티 모델 서빙,</a:t>
+            </a:r>
           </a:p>
           <a:p>
             <a:pPr>
@@ -12132,27 +12205,11 @@
                 <a:solidFill>
                   <a:srgbClr val="94A3B8"/>
                 </a:solidFill>
-                <a:latin typeface="Segoe UI"/>
-              </a:defRPr>
-            </a:pPr>
-            <a:r>
-              <a:t>5.  2x H200 GPUs (282GB total) enables multi-model serving,</a:t>
-            </a:r>
-          </a:p>
-          <a:p>
-            <a:pPr>
-              <a:spcAft>
-                <a:spcPts val="400"/>
-              </a:spcAft>
-              <a:defRPr sz="1500">
-                <a:solidFill>
-                  <a:srgbClr val="94A3B8"/>
-                </a:solidFill>
-                <a:latin typeface="Segoe UI"/>
-              </a:defRPr>
-            </a:pPr>
-            <a:r>
-              <a:t>     72B model access, fine-tuning, and future-proofing</a:t>
+                <a:latin typeface="Malgun Gothic"/>
+              </a:defRPr>
+            </a:pPr>
+            <a:r>
+              <a:t>     72B 대형 모델 운영, 파인튜닝, 미래 확장성 확보</a:t>
             </a:r>
           </a:p>
         </p:txBody>
@@ -12229,11 +12286,15 @@
                 <a:solidFill>
                   <a:srgbClr val="38BDF8"/>
                 </a:solidFill>
-                <a:latin typeface="Segoe UI"/>
-              </a:defRPr>
-            </a:pPr>
-            <a:r>
-              <a:t>Request: Approve procurement of 2x NVIDIA H200 SXM GPUs for self-hosted GUI-specialized VLM deployment and fine-tuning.</a:t>
+                <a:latin typeface="Malgun Gothic"/>
+              </a:defRPr>
+            </a:pPr>
+            <a:r>
+              <a:t>요청: GUI 자동화 전용 VLM 모델 배포 및 파인튜닝을 위한</a:t>
+            </a:r>
+            <a:br/>
+            <a:r>
+              <a:t>NVIDIA H200 SXM GPU 2대 도입을 승인해 주시기 바랍니다.</a:t>
             </a:r>
           </a:p>
         </p:txBody>

</xml_diff>